<commit_message>
Fix PowerPoint 16:9 widescreen layout dimensions and full-bleed background color
</commit_message>
<xml_diff>
--- a/EventEase_Presentation.pptx
+++ b/EventEase_Presentation.pptx
@@ -1749,7 +1749,7 @@
         <p:spPr>
           <a:xfrm>
             <a:off x="914400" y="1463040"/>
-            <a:ext cx="10332720" cy="1097280"/>
+            <a:ext cx="10360152" cy="1097280"/>
           </a:xfrm>
           <a:prstGeom prst="rect">
             <a:avLst/>
@@ -1765,7 +1765,7 @@
               <a:buNone/>
             </a:pPr>
             <a:r>
-              <a:rPr lang="en-US" sz="5400" b="1" dirty="0">
+              <a:rPr lang="en-US" sz="5600" b="1" dirty="0">
                 <a:solidFill>
                   <a:srgbClr val="FFFFFF"/>
                 </a:solidFill>
@@ -1775,7 +1775,7 @@
               </a:rPr>
               <a:t>EventEase</a:t>
             </a:r>
-            <a:endParaRPr lang="en-US" sz="5400" dirty="0"/>
+            <a:endParaRPr lang="en-US" sz="5600" dirty="0"/>
           </a:p>
         </p:txBody>
       </p:sp>
@@ -1788,7 +1788,7 @@
         <p:spPr>
           <a:xfrm>
             <a:off x="914400" y="2560320"/>
-            <a:ext cx="10332720" cy="548640"/>
+            <a:ext cx="10360152" cy="548640"/>
           </a:xfrm>
           <a:prstGeom prst="rect">
             <a:avLst/>
@@ -1827,7 +1827,7 @@
         <p:spPr>
           <a:xfrm>
             <a:off x="914400" y="3200400"/>
-            <a:ext cx="10332720" cy="457200"/>
+            <a:ext cx="10360152" cy="457200"/>
           </a:xfrm>
           <a:prstGeom prst="rect">
             <a:avLst/>
@@ -1865,8 +1865,8 @@
         </p:nvSpPr>
         <p:spPr>
           <a:xfrm>
-            <a:off x="1371600" y="4114800"/>
-            <a:ext cx="4389120" cy="1645920"/>
+            <a:off x="1097280" y="4114800"/>
+            <a:ext cx="4754880" cy="2011680"/>
           </a:xfrm>
           <a:prstGeom prst="roundRect">
             <a:avLst/>
@@ -1890,8 +1890,8 @@
         </p:nvSpPr>
         <p:spPr>
           <a:xfrm>
-            <a:off x="1645920" y="4297680"/>
-            <a:ext cx="3840480" cy="1280160"/>
+            <a:off x="1280160" y="4297680"/>
+            <a:ext cx="4389120" cy="1645920"/>
           </a:xfrm>
           <a:prstGeom prst="rect">
             <a:avLst/>
@@ -2002,7 +2002,7 @@
         <p:spPr>
           <a:xfrm>
             <a:off x="6309360" y="4114800"/>
-            <a:ext cx="4389120" cy="1645920"/>
+            <a:ext cx="4754880" cy="2011680"/>
           </a:xfrm>
           <a:prstGeom prst="roundRect">
             <a:avLst/>
@@ -2026,8 +2026,8 @@
         </p:nvSpPr>
         <p:spPr>
           <a:xfrm>
-            <a:off x="6583680" y="4297680"/>
-            <a:ext cx="3840480" cy="1280160"/>
+            <a:off x="6492240" y="4297680"/>
+            <a:ext cx="4389120" cy="1645920"/>
           </a:xfrm>
           <a:prstGeom prst="rect">
             <a:avLst/>
@@ -2169,8 +2169,8 @@
         </p:nvSpPr>
         <p:spPr>
           <a:xfrm>
-            <a:off x="914400" y="1645920"/>
-            <a:ext cx="10332720" cy="1097280"/>
+            <a:off x="914400" y="1371600"/>
+            <a:ext cx="10360152" cy="1097280"/>
           </a:xfrm>
           <a:prstGeom prst="rect">
             <a:avLst/>
@@ -2186,7 +2186,7 @@
               <a:buNone/>
             </a:pPr>
             <a:r>
-              <a:rPr lang="en-US" sz="5400" b="1" dirty="0">
+              <a:rPr lang="en-US" sz="5600" b="1" dirty="0">
                 <a:solidFill>
                   <a:srgbClr val="FFFFFF"/>
                 </a:solidFill>
@@ -2196,7 +2196,7 @@
               </a:rPr>
               <a:t>Thank You!</a:t>
             </a:r>
-            <a:endParaRPr lang="en-US" sz="5400" dirty="0"/>
+            <a:endParaRPr lang="en-US" sz="5600" dirty="0"/>
           </a:p>
         </p:txBody>
       </p:sp>
@@ -2208,8 +2208,8 @@
         </p:nvSpPr>
         <p:spPr>
           <a:xfrm>
-            <a:off x="914400" y="2743200"/>
-            <a:ext cx="10332720" cy="548640"/>
+            <a:off x="914400" y="2468880"/>
+            <a:ext cx="10360152" cy="548640"/>
           </a:xfrm>
           <a:prstGeom prst="rect">
             <a:avLst/>
@@ -2247,8 +2247,8 @@
         </p:nvSpPr>
         <p:spPr>
           <a:xfrm>
-            <a:off x="2743200" y="3657600"/>
-            <a:ext cx="6675120" cy="2011680"/>
+            <a:off x="2286000" y="3291840"/>
+            <a:ext cx="7616952" cy="2560320"/>
           </a:xfrm>
           <a:prstGeom prst="roundRect">
             <a:avLst/>
@@ -2272,8 +2272,8 @@
         </p:nvSpPr>
         <p:spPr>
           <a:xfrm>
-            <a:off x="3017520" y="3840480"/>
-            <a:ext cx="6126480" cy="1645920"/>
+            <a:off x="2560320" y="3474720"/>
+            <a:ext cx="7068312" cy="2194560"/>
           </a:xfrm>
           <a:prstGeom prst="rect">
             <a:avLst/>
@@ -2411,8 +2411,8 @@
         </p:nvSpPr>
         <p:spPr>
           <a:xfrm>
-            <a:off x="731520" y="457200"/>
-            <a:ext cx="10515600" cy="731520"/>
+            <a:off x="731520" y="365760"/>
+            <a:ext cx="10698480" cy="731520"/>
           </a:xfrm>
           <a:prstGeom prst="rect">
             <a:avLst/>
@@ -2450,8 +2450,8 @@
         </p:nvSpPr>
         <p:spPr>
           <a:xfrm>
-            <a:off x="731520" y="1188720"/>
-            <a:ext cx="10698480" cy="0"/>
+            <a:off x="731520" y="1143000"/>
+            <a:ext cx="10725912" cy="0"/>
           </a:xfrm>
           <a:prstGeom prst="line">
             <a:avLst/>
@@ -2473,8 +2473,8 @@
         </p:nvSpPr>
         <p:spPr>
           <a:xfrm>
-            <a:off x="731520" y="1463040"/>
-            <a:ext cx="5120640" cy="4389120"/>
+            <a:off x="731520" y="1371600"/>
+            <a:ext cx="5120640" cy="4846320"/>
           </a:xfrm>
           <a:prstGeom prst="roundRect">
             <a:avLst/>
@@ -2498,7 +2498,7 @@
         </p:nvSpPr>
         <p:spPr>
           <a:xfrm>
-            <a:off x="1005840" y="1737360"/>
+            <a:off x="1005840" y="1554480"/>
             <a:ext cx="4572000" cy="457200"/>
           </a:xfrm>
           <a:prstGeom prst="rect">
@@ -2537,8 +2537,8 @@
         </p:nvSpPr>
         <p:spPr>
           <a:xfrm>
-            <a:off x="1005840" y="2286000"/>
-            <a:ext cx="4572000" cy="3291840"/>
+            <a:off x="1005840" y="2103120"/>
+            <a:ext cx="4572000" cy="3931920"/>
           </a:xfrm>
           <a:prstGeom prst="rect">
             <a:avLst/>
@@ -2648,8 +2648,8 @@
         </p:nvSpPr>
         <p:spPr>
           <a:xfrm>
-            <a:off x="6217920" y="1463040"/>
-            <a:ext cx="5120640" cy="4389120"/>
+            <a:off x="6217920" y="1371600"/>
+            <a:ext cx="5120640" cy="4846320"/>
           </a:xfrm>
           <a:prstGeom prst="roundRect">
             <a:avLst/>
@@ -2673,7 +2673,7 @@
         </p:nvSpPr>
         <p:spPr>
           <a:xfrm>
-            <a:off x="6492240" y="1737360"/>
+            <a:off x="6492240" y="1554480"/>
             <a:ext cx="4572000" cy="457200"/>
           </a:xfrm>
           <a:prstGeom prst="rect">
@@ -2712,8 +2712,8 @@
         </p:nvSpPr>
         <p:spPr>
           <a:xfrm>
-            <a:off x="6492240" y="2286000"/>
-            <a:ext cx="4572000" cy="3291840"/>
+            <a:off x="6492240" y="2103120"/>
+            <a:ext cx="4572000" cy="3931920"/>
           </a:xfrm>
           <a:prstGeom prst="rect">
             <a:avLst/>
@@ -2855,8 +2855,8 @@
         </p:nvSpPr>
         <p:spPr>
           <a:xfrm>
-            <a:off x="731520" y="457200"/>
-            <a:ext cx="10515600" cy="731520"/>
+            <a:off x="731520" y="365760"/>
+            <a:ext cx="10698480" cy="731520"/>
           </a:xfrm>
           <a:prstGeom prst="rect">
             <a:avLst/>
@@ -2894,8 +2894,8 @@
         </p:nvSpPr>
         <p:spPr>
           <a:xfrm>
-            <a:off x="731520" y="1188720"/>
-            <a:ext cx="10698480" cy="0"/>
+            <a:off x="731520" y="1143000"/>
+            <a:ext cx="10725912" cy="0"/>
           </a:xfrm>
           <a:prstGeom prst="line">
             <a:avLst/>
@@ -2917,8 +2917,8 @@
         </p:nvSpPr>
         <p:spPr>
           <a:xfrm>
-            <a:off x="731520" y="1463040"/>
-            <a:ext cx="3383280" cy="2011680"/>
+            <a:off x="731520" y="1371600"/>
+            <a:ext cx="3383280" cy="2194560"/>
           </a:xfrm>
           <a:prstGeom prst="roundRect">
             <a:avLst/>
@@ -2942,7 +2942,7 @@
         </p:nvSpPr>
         <p:spPr>
           <a:xfrm>
-            <a:off x="914400" y="1645920"/>
+            <a:off x="914400" y="1554480"/>
             <a:ext cx="3017520" cy="365760"/>
           </a:xfrm>
           <a:prstGeom prst="rect">
@@ -2981,8 +2981,8 @@
         </p:nvSpPr>
         <p:spPr>
           <a:xfrm>
-            <a:off x="914400" y="2103120"/>
-            <a:ext cx="3017520" cy="1188720"/>
+            <a:off x="914400" y="2011680"/>
+            <a:ext cx="3017520" cy="1371600"/>
           </a:xfrm>
           <a:prstGeom prst="rect">
             <a:avLst/>
@@ -3020,8 +3020,8 @@
         </p:nvSpPr>
         <p:spPr>
           <a:xfrm>
-            <a:off x="4389120" y="1463040"/>
-            <a:ext cx="3383280" cy="2011680"/>
+            <a:off x="4389120" y="1371600"/>
+            <a:ext cx="3383280" cy="2194560"/>
           </a:xfrm>
           <a:prstGeom prst="roundRect">
             <a:avLst/>
@@ -3045,7 +3045,7 @@
         </p:nvSpPr>
         <p:spPr>
           <a:xfrm>
-            <a:off x="4572000" y="1645920"/>
+            <a:off x="4572000" y="1554480"/>
             <a:ext cx="3017520" cy="365760"/>
           </a:xfrm>
           <a:prstGeom prst="rect">
@@ -3084,8 +3084,8 @@
         </p:nvSpPr>
         <p:spPr>
           <a:xfrm>
-            <a:off x="4572000" y="2103120"/>
-            <a:ext cx="3017520" cy="1188720"/>
+            <a:off x="4572000" y="2011680"/>
+            <a:ext cx="3017520" cy="1371600"/>
           </a:xfrm>
           <a:prstGeom prst="rect">
             <a:avLst/>
@@ -3123,8 +3123,8 @@
         </p:nvSpPr>
         <p:spPr>
           <a:xfrm>
-            <a:off x="8046720" y="1463040"/>
-            <a:ext cx="3383280" cy="2011680"/>
+            <a:off x="8046720" y="1371600"/>
+            <a:ext cx="3383280" cy="2194560"/>
           </a:xfrm>
           <a:prstGeom prst="roundRect">
             <a:avLst/>
@@ -3148,7 +3148,7 @@
         </p:nvSpPr>
         <p:spPr>
           <a:xfrm>
-            <a:off x="8229600" y="1645920"/>
+            <a:off x="8229600" y="1554480"/>
             <a:ext cx="3017520" cy="365760"/>
           </a:xfrm>
           <a:prstGeom prst="rect">
@@ -3187,8 +3187,8 @@
         </p:nvSpPr>
         <p:spPr>
           <a:xfrm>
-            <a:off x="8229600" y="2103120"/>
-            <a:ext cx="3017520" cy="1188720"/>
+            <a:off x="8229600" y="2011680"/>
+            <a:ext cx="3017520" cy="1371600"/>
           </a:xfrm>
           <a:prstGeom prst="rect">
             <a:avLst/>
@@ -3226,8 +3226,8 @@
         </p:nvSpPr>
         <p:spPr>
           <a:xfrm>
-            <a:off x="731520" y="3749040"/>
-            <a:ext cx="3383280" cy="2011680"/>
+            <a:off x="731520" y="3840480"/>
+            <a:ext cx="3383280" cy="2194560"/>
           </a:xfrm>
           <a:prstGeom prst="roundRect">
             <a:avLst/>
@@ -3251,7 +3251,7 @@
         </p:nvSpPr>
         <p:spPr>
           <a:xfrm>
-            <a:off x="914400" y="3931920"/>
+            <a:off x="914400" y="4023360"/>
             <a:ext cx="3017520" cy="365760"/>
           </a:xfrm>
           <a:prstGeom prst="rect">
@@ -3290,8 +3290,8 @@
         </p:nvSpPr>
         <p:spPr>
           <a:xfrm>
-            <a:off x="914400" y="4389120"/>
-            <a:ext cx="3017520" cy="1188720"/>
+            <a:off x="914400" y="4480560"/>
+            <a:ext cx="3017520" cy="1371600"/>
           </a:xfrm>
           <a:prstGeom prst="rect">
             <a:avLst/>
@@ -3329,8 +3329,8 @@
         </p:nvSpPr>
         <p:spPr>
           <a:xfrm>
-            <a:off x="4389120" y="3749040"/>
-            <a:ext cx="3383280" cy="2011680"/>
+            <a:off x="4389120" y="3840480"/>
+            <a:ext cx="3383280" cy="2194560"/>
           </a:xfrm>
           <a:prstGeom prst="roundRect">
             <a:avLst/>
@@ -3354,7 +3354,7 @@
         </p:nvSpPr>
         <p:spPr>
           <a:xfrm>
-            <a:off x="4572000" y="3931920"/>
+            <a:off x="4572000" y="4023360"/>
             <a:ext cx="3017520" cy="365760"/>
           </a:xfrm>
           <a:prstGeom prst="rect">
@@ -3393,8 +3393,8 @@
         </p:nvSpPr>
         <p:spPr>
           <a:xfrm>
-            <a:off x="4572000" y="4389120"/>
-            <a:ext cx="3017520" cy="1188720"/>
+            <a:off x="4572000" y="4480560"/>
+            <a:ext cx="3017520" cy="1371600"/>
           </a:xfrm>
           <a:prstGeom prst="rect">
             <a:avLst/>
@@ -3432,8 +3432,8 @@
         </p:nvSpPr>
         <p:spPr>
           <a:xfrm>
-            <a:off x="8046720" y="3749040"/>
-            <a:ext cx="3383280" cy="2011680"/>
+            <a:off x="8046720" y="3840480"/>
+            <a:ext cx="3383280" cy="2194560"/>
           </a:xfrm>
           <a:prstGeom prst="roundRect">
             <a:avLst/>
@@ -3457,7 +3457,7 @@
         </p:nvSpPr>
         <p:spPr>
           <a:xfrm>
-            <a:off x="8229600" y="3931920"/>
+            <a:off x="8229600" y="4023360"/>
             <a:ext cx="3017520" cy="365760"/>
           </a:xfrm>
           <a:prstGeom prst="rect">
@@ -3496,8 +3496,8 @@
         </p:nvSpPr>
         <p:spPr>
           <a:xfrm>
-            <a:off x="8229600" y="4389120"/>
-            <a:ext cx="3017520" cy="1188720"/>
+            <a:off x="8229600" y="4480560"/>
+            <a:ext cx="3017520" cy="1371600"/>
           </a:xfrm>
           <a:prstGeom prst="rect">
             <a:avLst/>
@@ -3567,8 +3567,8 @@
         </p:nvSpPr>
         <p:spPr>
           <a:xfrm>
-            <a:off x="731520" y="457200"/>
-            <a:ext cx="10515600" cy="731520"/>
+            <a:off x="731520" y="365760"/>
+            <a:ext cx="10698480" cy="731520"/>
           </a:xfrm>
           <a:prstGeom prst="rect">
             <a:avLst/>
@@ -3606,8 +3606,8 @@
         </p:nvSpPr>
         <p:spPr>
           <a:xfrm>
-            <a:off x="731520" y="1188720"/>
-            <a:ext cx="10698480" cy="0"/>
+            <a:off x="731520" y="1143000"/>
+            <a:ext cx="10725912" cy="0"/>
           </a:xfrm>
           <a:prstGeom prst="line">
             <a:avLst/>
@@ -3629,7 +3629,7 @@
         </p:nvSpPr>
         <p:spPr>
           <a:xfrm>
-            <a:off x="731520" y="1645920"/>
+            <a:off x="731520" y="1463040"/>
             <a:ext cx="3200400" cy="1828800"/>
           </a:xfrm>
           <a:prstGeom prst="roundRect">
@@ -3654,7 +3654,7 @@
         </p:nvSpPr>
         <p:spPr>
           <a:xfrm>
-            <a:off x="822960" y="1828800"/>
+            <a:off x="822960" y="1645920"/>
             <a:ext cx="3017520" cy="1463040"/>
           </a:xfrm>
           <a:prstGeom prst="rect">
@@ -3750,7 +3750,7 @@
         </p:nvSpPr>
         <p:spPr>
           <a:xfrm>
-            <a:off x="4114800" y="2286000"/>
+            <a:off x="4114800" y="2103120"/>
             <a:ext cx="548640" cy="548640"/>
           </a:xfrm>
           <a:prstGeom prst="rect">
@@ -3786,7 +3786,7 @@
         </p:nvSpPr>
         <p:spPr>
           <a:xfrm>
-            <a:off x="4846320" y="1645920"/>
+            <a:off x="4846320" y="1463040"/>
             <a:ext cx="3200400" cy="1828800"/>
           </a:xfrm>
           <a:prstGeom prst="roundRect">
@@ -3811,7 +3811,7 @@
         </p:nvSpPr>
         <p:spPr>
           <a:xfrm>
-            <a:off x="4937760" y="1828800"/>
+            <a:off x="4937760" y="1645920"/>
             <a:ext cx="3017520" cy="1463040"/>
           </a:xfrm>
           <a:prstGeom prst="rect">
@@ -3907,7 +3907,7 @@
         </p:nvSpPr>
         <p:spPr>
           <a:xfrm>
-            <a:off x="8229600" y="2286000"/>
+            <a:off x="8229600" y="2103120"/>
             <a:ext cx="548640" cy="548640"/>
           </a:xfrm>
           <a:prstGeom prst="rect">
@@ -3943,7 +3943,7 @@
         </p:nvSpPr>
         <p:spPr>
           <a:xfrm>
-            <a:off x="8869680" y="1645920"/>
+            <a:off x="8869680" y="1463040"/>
             <a:ext cx="2560320" cy="1828800"/>
           </a:xfrm>
           <a:prstGeom prst="roundRect">
@@ -3968,7 +3968,7 @@
         </p:nvSpPr>
         <p:spPr>
           <a:xfrm>
-            <a:off x="8961120" y="1828800"/>
+            <a:off x="8961120" y="1645920"/>
             <a:ext cx="2377440" cy="1463040"/>
           </a:xfrm>
           <a:prstGeom prst="rect">
@@ -4064,8 +4064,8 @@
         </p:nvSpPr>
         <p:spPr>
           <a:xfrm>
-            <a:off x="731520" y="3931920"/>
-            <a:ext cx="10698480" cy="1828800"/>
+            <a:off x="731520" y="3657600"/>
+            <a:ext cx="10725912" cy="2560320"/>
           </a:xfrm>
           <a:prstGeom prst="roundRect">
             <a:avLst/>
@@ -4089,7 +4089,7 @@
         </p:nvSpPr>
         <p:spPr>
           <a:xfrm>
-            <a:off x="1005840" y="4114800"/>
+            <a:off x="1005840" y="3840480"/>
             <a:ext cx="10058400" cy="365760"/>
           </a:xfrm>
           <a:prstGeom prst="rect">
@@ -4128,8 +4128,8 @@
         </p:nvSpPr>
         <p:spPr>
           <a:xfrm>
-            <a:off x="1005840" y="4480560"/>
-            <a:ext cx="10058400" cy="1097280"/>
+            <a:off x="1005840" y="4297680"/>
+            <a:ext cx="10058400" cy="1737360"/>
           </a:xfrm>
           <a:prstGeom prst="rect">
             <a:avLst/>
@@ -4250,8 +4250,8 @@
         </p:nvSpPr>
         <p:spPr>
           <a:xfrm>
-            <a:off x="731520" y="457200"/>
-            <a:ext cx="10515600" cy="731520"/>
+            <a:off x="731520" y="365760"/>
+            <a:ext cx="10698480" cy="731520"/>
           </a:xfrm>
           <a:prstGeom prst="rect">
             <a:avLst/>
@@ -4289,8 +4289,8 @@
         </p:nvSpPr>
         <p:spPr>
           <a:xfrm>
-            <a:off x="731520" y="1188720"/>
-            <a:ext cx="10698480" cy="0"/>
+            <a:off x="731520" y="1143000"/>
+            <a:ext cx="10725912" cy="0"/>
           </a:xfrm>
           <a:prstGeom prst="line">
             <a:avLst/>
@@ -4319,8 +4319,8 @@
           </p:nvPr>
         </p:nvGraphicFramePr>
         <p:xfrm>
-          <a:off x="731520" y="1463040"/>
-          <a:ext cx="10698480" cy="914400"/>
+          <a:off x="731520" y="1371600"/>
+          <a:ext cx="10725912" cy="914400"/>
         </p:xfrm>
         <a:graphic>
           <a:graphicData uri="http://schemas.openxmlformats.org/drawingml/2006/table">
@@ -4329,7 +4329,7 @@
               <a:tblGrid>
                 <a:gridCol w="2286000"/>
                 <a:gridCol w="2926080"/>
-                <a:gridCol w="5486400"/>
+                <a:gridCol w="5513832"/>
               </a:tblGrid>
               <a:tr h="0">
                 <a:tc>
@@ -5960,8 +5960,8 @@
         </p:nvSpPr>
         <p:spPr>
           <a:xfrm>
-            <a:off x="731520" y="457200"/>
-            <a:ext cx="10515600" cy="731520"/>
+            <a:off x="731520" y="365760"/>
+            <a:ext cx="10698480" cy="731520"/>
           </a:xfrm>
           <a:prstGeom prst="rect">
             <a:avLst/>
@@ -5999,8 +5999,8 @@
         </p:nvSpPr>
         <p:spPr>
           <a:xfrm>
-            <a:off x="731520" y="1188720"/>
-            <a:ext cx="10698480" cy="0"/>
+            <a:off x="731520" y="1143000"/>
+            <a:ext cx="10725912" cy="0"/>
           </a:xfrm>
           <a:prstGeom prst="line">
             <a:avLst/>
@@ -6022,8 +6022,8 @@
         </p:nvSpPr>
         <p:spPr>
           <a:xfrm>
-            <a:off x="731520" y="1463040"/>
-            <a:ext cx="10698480" cy="1371600"/>
+            <a:off x="731520" y="1371600"/>
+            <a:ext cx="10725912" cy="1371600"/>
           </a:xfrm>
           <a:prstGeom prst="roundRect">
             <a:avLst/>
@@ -6047,7 +6047,7 @@
         </p:nvSpPr>
         <p:spPr>
           <a:xfrm>
-            <a:off x="1005840" y="1645920"/>
+            <a:off x="1005840" y="1554480"/>
             <a:ext cx="10058400" cy="365760"/>
           </a:xfrm>
           <a:prstGeom prst="rect">
@@ -6086,7 +6086,7 @@
         </p:nvSpPr>
         <p:spPr>
           <a:xfrm>
-            <a:off x="1005840" y="2103120"/>
+            <a:off x="1005840" y="2011680"/>
             <a:ext cx="10058400" cy="457200"/>
           </a:xfrm>
           <a:prstGeom prst="rect">
@@ -6125,8 +6125,8 @@
         </p:nvSpPr>
         <p:spPr>
           <a:xfrm>
-            <a:off x="731520" y="3108960"/>
-            <a:ext cx="5120640" cy="2743200"/>
+            <a:off x="731520" y="3017520"/>
+            <a:ext cx="5120640" cy="3200400"/>
           </a:xfrm>
           <a:prstGeom prst="roundRect">
             <a:avLst/>
@@ -6150,7 +6150,7 @@
         </p:nvSpPr>
         <p:spPr>
           <a:xfrm>
-            <a:off x="1005840" y="3383280"/>
+            <a:off x="1005840" y="3291840"/>
             <a:ext cx="4572000" cy="365760"/>
           </a:xfrm>
           <a:prstGeom prst="rect">
@@ -6189,8 +6189,8 @@
         </p:nvSpPr>
         <p:spPr>
           <a:xfrm>
-            <a:off x="1005840" y="3931920"/>
-            <a:ext cx="4572000" cy="1645920"/>
+            <a:off x="1005840" y="3840480"/>
+            <a:ext cx="4572000" cy="2103120"/>
           </a:xfrm>
           <a:prstGeom prst="rect">
             <a:avLst/>
@@ -6262,8 +6262,8 @@
         </p:nvSpPr>
         <p:spPr>
           <a:xfrm>
-            <a:off x="6217920" y="3108960"/>
-            <a:ext cx="5120640" cy="2743200"/>
+            <a:off x="6217920" y="3017520"/>
+            <a:ext cx="5120640" cy="3200400"/>
           </a:xfrm>
           <a:prstGeom prst="roundRect">
             <a:avLst/>
@@ -6287,7 +6287,7 @@
         </p:nvSpPr>
         <p:spPr>
           <a:xfrm>
-            <a:off x="6492240" y="3383280"/>
+            <a:off x="6492240" y="3291840"/>
             <a:ext cx="4572000" cy="365760"/>
           </a:xfrm>
           <a:prstGeom prst="rect">
@@ -6326,8 +6326,8 @@
         </p:nvSpPr>
         <p:spPr>
           <a:xfrm>
-            <a:off x="6492240" y="3931920"/>
-            <a:ext cx="4572000" cy="1645920"/>
+            <a:off x="6492240" y="3840480"/>
+            <a:ext cx="4572000" cy="2103120"/>
           </a:xfrm>
           <a:prstGeom prst="rect">
             <a:avLst/>
@@ -6431,8 +6431,8 @@
         </p:nvSpPr>
         <p:spPr>
           <a:xfrm>
-            <a:off x="731520" y="457200"/>
-            <a:ext cx="10515600" cy="731520"/>
+            <a:off x="731520" y="365760"/>
+            <a:ext cx="10698480" cy="731520"/>
           </a:xfrm>
           <a:prstGeom prst="rect">
             <a:avLst/>
@@ -6470,8 +6470,8 @@
         </p:nvSpPr>
         <p:spPr>
           <a:xfrm>
-            <a:off x="731520" y="1188720"/>
-            <a:ext cx="10698480" cy="0"/>
+            <a:off x="731520" y="1143000"/>
+            <a:ext cx="10725912" cy="0"/>
           </a:xfrm>
           <a:prstGeom prst="line">
             <a:avLst/>
@@ -6493,8 +6493,8 @@
         </p:nvSpPr>
         <p:spPr>
           <a:xfrm>
-            <a:off x="731520" y="1463040"/>
-            <a:ext cx="3383280" cy="4389120"/>
+            <a:off x="731520" y="1371600"/>
+            <a:ext cx="3383280" cy="4846320"/>
           </a:xfrm>
           <a:prstGeom prst="roundRect">
             <a:avLst/>
@@ -6518,7 +6518,7 @@
         </p:nvSpPr>
         <p:spPr>
           <a:xfrm>
-            <a:off x="914400" y="1737360"/>
+            <a:off x="914400" y="1645920"/>
             <a:ext cx="3017520" cy="457200"/>
           </a:xfrm>
           <a:prstGeom prst="rect">
@@ -6557,7 +6557,7 @@
         </p:nvSpPr>
         <p:spPr>
           <a:xfrm>
-            <a:off x="914400" y="2194560"/>
+            <a:off x="914400" y="2103120"/>
             <a:ext cx="3017520" cy="365760"/>
           </a:xfrm>
           <a:prstGeom prst="rect">
@@ -6596,8 +6596,8 @@
         </p:nvSpPr>
         <p:spPr>
           <a:xfrm>
-            <a:off x="914400" y="2743200"/>
-            <a:ext cx="3017520" cy="2743200"/>
+            <a:off x="914400" y="2651760"/>
+            <a:ext cx="3017520" cy="3200400"/>
           </a:xfrm>
           <a:prstGeom prst="rect">
             <a:avLst/>
@@ -6635,8 +6635,8 @@
         </p:nvSpPr>
         <p:spPr>
           <a:xfrm>
-            <a:off x="4389120" y="1463040"/>
-            <a:ext cx="3383280" cy="4389120"/>
+            <a:off x="4389120" y="1371600"/>
+            <a:ext cx="3383280" cy="4846320"/>
           </a:xfrm>
           <a:prstGeom prst="roundRect">
             <a:avLst/>
@@ -6660,7 +6660,7 @@
         </p:nvSpPr>
         <p:spPr>
           <a:xfrm>
-            <a:off x="4572000" y="1737360"/>
+            <a:off x="4572000" y="1645920"/>
             <a:ext cx="3017520" cy="457200"/>
           </a:xfrm>
           <a:prstGeom prst="rect">
@@ -6699,7 +6699,7 @@
         </p:nvSpPr>
         <p:spPr>
           <a:xfrm>
-            <a:off x="4572000" y="2194560"/>
+            <a:off x="4572000" y="2103120"/>
             <a:ext cx="3017520" cy="365760"/>
           </a:xfrm>
           <a:prstGeom prst="rect">
@@ -6738,8 +6738,8 @@
         </p:nvSpPr>
         <p:spPr>
           <a:xfrm>
-            <a:off x="4572000" y="2743200"/>
-            <a:ext cx="3017520" cy="2743200"/>
+            <a:off x="4572000" y="2651760"/>
+            <a:ext cx="3017520" cy="3200400"/>
           </a:xfrm>
           <a:prstGeom prst="rect">
             <a:avLst/>
@@ -6777,8 +6777,8 @@
         </p:nvSpPr>
         <p:spPr>
           <a:xfrm>
-            <a:off x="8046720" y="1463040"/>
-            <a:ext cx="3383280" cy="4389120"/>
+            <a:off x="8046720" y="1371600"/>
+            <a:ext cx="3383280" cy="4846320"/>
           </a:xfrm>
           <a:prstGeom prst="roundRect">
             <a:avLst/>
@@ -6802,7 +6802,7 @@
         </p:nvSpPr>
         <p:spPr>
           <a:xfrm>
-            <a:off x="8229600" y="1737360"/>
+            <a:off x="8229600" y="1645920"/>
             <a:ext cx="3017520" cy="457200"/>
           </a:xfrm>
           <a:prstGeom prst="rect">
@@ -6841,7 +6841,7 @@
         </p:nvSpPr>
         <p:spPr>
           <a:xfrm>
-            <a:off x="8229600" y="2194560"/>
+            <a:off x="8229600" y="2103120"/>
             <a:ext cx="3017520" cy="365760"/>
           </a:xfrm>
           <a:prstGeom prst="rect">
@@ -6880,8 +6880,8 @@
         </p:nvSpPr>
         <p:spPr>
           <a:xfrm>
-            <a:off x="8229600" y="2743200"/>
-            <a:ext cx="3017520" cy="2743200"/>
+            <a:off x="8229600" y="2651760"/>
+            <a:ext cx="3017520" cy="3200400"/>
           </a:xfrm>
           <a:prstGeom prst="rect">
             <a:avLst/>
@@ -6951,8 +6951,8 @@
         </p:nvSpPr>
         <p:spPr>
           <a:xfrm>
-            <a:off x="731520" y="457200"/>
-            <a:ext cx="10515600" cy="731520"/>
+            <a:off x="731520" y="365760"/>
+            <a:ext cx="10698480" cy="731520"/>
           </a:xfrm>
           <a:prstGeom prst="rect">
             <a:avLst/>
@@ -6990,8 +6990,8 @@
         </p:nvSpPr>
         <p:spPr>
           <a:xfrm>
-            <a:off x="731520" y="1188720"/>
-            <a:ext cx="10698480" cy="0"/>
+            <a:off x="731520" y="1143000"/>
+            <a:ext cx="10725912" cy="0"/>
           </a:xfrm>
           <a:prstGeom prst="line">
             <a:avLst/>
@@ -7013,8 +7013,8 @@
         </p:nvSpPr>
         <p:spPr>
           <a:xfrm>
-            <a:off x="731520" y="1463040"/>
-            <a:ext cx="5120640" cy="4389120"/>
+            <a:off x="731520" y="1371600"/>
+            <a:ext cx="5120640" cy="4846320"/>
           </a:xfrm>
           <a:prstGeom prst="roundRect">
             <a:avLst/>
@@ -7038,7 +7038,7 @@
         </p:nvSpPr>
         <p:spPr>
           <a:xfrm>
-            <a:off x="1005840" y="1737360"/>
+            <a:off x="1005840" y="1645920"/>
             <a:ext cx="4572000" cy="365760"/>
           </a:xfrm>
           <a:prstGeom prst="rect">
@@ -7077,8 +7077,8 @@
         </p:nvSpPr>
         <p:spPr>
           <a:xfrm>
-            <a:off x="1005840" y="2286000"/>
-            <a:ext cx="4572000" cy="3291840"/>
+            <a:off x="1005840" y="2194560"/>
+            <a:ext cx="4572000" cy="3749040"/>
           </a:xfrm>
           <a:prstGeom prst="rect">
             <a:avLst/>
@@ -7213,8 +7213,8 @@
         </p:nvSpPr>
         <p:spPr>
           <a:xfrm>
-            <a:off x="6217920" y="1463040"/>
-            <a:ext cx="5120640" cy="4389120"/>
+            <a:off x="6217920" y="1371600"/>
+            <a:ext cx="5120640" cy="4846320"/>
           </a:xfrm>
           <a:prstGeom prst="roundRect">
             <a:avLst/>
@@ -7238,7 +7238,7 @@
         </p:nvSpPr>
         <p:spPr>
           <a:xfrm>
-            <a:off x="6492240" y="1737360"/>
+            <a:off x="6492240" y="1645920"/>
             <a:ext cx="4572000" cy="365760"/>
           </a:xfrm>
           <a:prstGeom prst="rect">
@@ -7277,8 +7277,8 @@
         </p:nvSpPr>
         <p:spPr>
           <a:xfrm>
-            <a:off x="6492240" y="2286000"/>
-            <a:ext cx="4572000" cy="3291840"/>
+            <a:off x="6492240" y="2194560"/>
+            <a:ext cx="4572000" cy="3749040"/>
           </a:xfrm>
           <a:prstGeom prst="rect">
             <a:avLst/>
@@ -7422,8 +7422,8 @@
         </p:nvSpPr>
         <p:spPr>
           <a:xfrm>
-            <a:off x="731520" y="457200"/>
-            <a:ext cx="10515600" cy="731520"/>
+            <a:off x="731520" y="365760"/>
+            <a:ext cx="10698480" cy="731520"/>
           </a:xfrm>
           <a:prstGeom prst="rect">
             <a:avLst/>
@@ -7461,8 +7461,8 @@
         </p:nvSpPr>
         <p:spPr>
           <a:xfrm>
-            <a:off x="731520" y="1188720"/>
-            <a:ext cx="10698480" cy="0"/>
+            <a:off x="731520" y="1143000"/>
+            <a:ext cx="10725912" cy="0"/>
           </a:xfrm>
           <a:prstGeom prst="line">
             <a:avLst/>
@@ -7484,8 +7484,8 @@
         </p:nvSpPr>
         <p:spPr>
           <a:xfrm>
-            <a:off x="731520" y="1463040"/>
-            <a:ext cx="3383280" cy="4389120"/>
+            <a:off x="731520" y="1371600"/>
+            <a:ext cx="3383280" cy="4846320"/>
           </a:xfrm>
           <a:prstGeom prst="roundRect">
             <a:avLst/>
@@ -7509,7 +7509,7 @@
         </p:nvSpPr>
         <p:spPr>
           <a:xfrm>
-            <a:off x="914400" y="1828800"/>
+            <a:off x="914400" y="1737360"/>
             <a:ext cx="3017520" cy="731520"/>
           </a:xfrm>
           <a:prstGeom prst="rect">
@@ -7548,8 +7548,8 @@
         </p:nvSpPr>
         <p:spPr>
           <a:xfrm>
-            <a:off x="914400" y="2743200"/>
-            <a:ext cx="3017520" cy="2743200"/>
+            <a:off x="914400" y="2651760"/>
+            <a:ext cx="3017520" cy="3200400"/>
           </a:xfrm>
           <a:prstGeom prst="rect">
             <a:avLst/>
@@ -7587,8 +7587,8 @@
         </p:nvSpPr>
         <p:spPr>
           <a:xfrm>
-            <a:off x="4389120" y="1463040"/>
-            <a:ext cx="3383280" cy="4389120"/>
+            <a:off x="4389120" y="1371600"/>
+            <a:ext cx="3383280" cy="4846320"/>
           </a:xfrm>
           <a:prstGeom prst="roundRect">
             <a:avLst/>
@@ -7612,7 +7612,7 @@
         </p:nvSpPr>
         <p:spPr>
           <a:xfrm>
-            <a:off x="4572000" y="1828800"/>
+            <a:off x="4572000" y="1737360"/>
             <a:ext cx="3017520" cy="731520"/>
           </a:xfrm>
           <a:prstGeom prst="rect">
@@ -7651,8 +7651,8 @@
         </p:nvSpPr>
         <p:spPr>
           <a:xfrm>
-            <a:off x="4572000" y="2743200"/>
-            <a:ext cx="3017520" cy="2743200"/>
+            <a:off x="4572000" y="2651760"/>
+            <a:ext cx="3017520" cy="3200400"/>
           </a:xfrm>
           <a:prstGeom prst="rect">
             <a:avLst/>
@@ -7690,8 +7690,8 @@
         </p:nvSpPr>
         <p:spPr>
           <a:xfrm>
-            <a:off x="8046720" y="1463040"/>
-            <a:ext cx="3383280" cy="4389120"/>
+            <a:off x="8046720" y="1371600"/>
+            <a:ext cx="3383280" cy="4846320"/>
           </a:xfrm>
           <a:prstGeom prst="roundRect">
             <a:avLst/>
@@ -7715,7 +7715,7 @@
         </p:nvSpPr>
         <p:spPr>
           <a:xfrm>
-            <a:off x="8229600" y="1828800"/>
+            <a:off x="8229600" y="1737360"/>
             <a:ext cx="3017520" cy="731520"/>
           </a:xfrm>
           <a:prstGeom prst="rect">
@@ -7754,8 +7754,8 @@
         </p:nvSpPr>
         <p:spPr>
           <a:xfrm>
-            <a:off x="8229600" y="2743200"/>
-            <a:ext cx="3017520" cy="2743200"/>
+            <a:off x="8229600" y="2651760"/>
+            <a:ext cx="3017520" cy="3200400"/>
           </a:xfrm>
           <a:prstGeom prst="rect">
             <a:avLst/>

</xml_diff>

<commit_message>
Fix background fill property syntax for native full-screen slide rendering
</commit_message>
<xml_diff>
--- a/EventEase_Presentation.pptx
+++ b/EventEase_Presentation.pptx
@@ -2412,7 +2412,7 @@
         <p:spPr>
           <a:xfrm>
             <a:off x="731520" y="365760"/>
-            <a:ext cx="10698480" cy="731520"/>
+            <a:ext cx="10725912" cy="640080"/>
           </a:xfrm>
           <a:prstGeom prst="rect">
             <a:avLst/>
@@ -2450,7 +2450,7 @@
         </p:nvSpPr>
         <p:spPr>
           <a:xfrm>
-            <a:off x="731520" y="1143000"/>
+            <a:off x="731520" y="1097280"/>
             <a:ext cx="10725912" cy="0"/>
           </a:xfrm>
           <a:prstGeom prst="line">
@@ -2856,7 +2856,7 @@
         <p:spPr>
           <a:xfrm>
             <a:off x="731520" y="365760"/>
-            <a:ext cx="10698480" cy="731520"/>
+            <a:ext cx="10725912" cy="640080"/>
           </a:xfrm>
           <a:prstGeom prst="rect">
             <a:avLst/>
@@ -2894,7 +2894,7 @@
         </p:nvSpPr>
         <p:spPr>
           <a:xfrm>
-            <a:off x="731520" y="1143000"/>
+            <a:off x="731520" y="1097280"/>
             <a:ext cx="10725912" cy="0"/>
           </a:xfrm>
           <a:prstGeom prst="line">
@@ -3568,7 +3568,7 @@
         <p:spPr>
           <a:xfrm>
             <a:off x="731520" y="365760"/>
-            <a:ext cx="10698480" cy="731520"/>
+            <a:ext cx="10725912" cy="640080"/>
           </a:xfrm>
           <a:prstGeom prst="rect">
             <a:avLst/>
@@ -3606,7 +3606,7 @@
         </p:nvSpPr>
         <p:spPr>
           <a:xfrm>
-            <a:off x="731520" y="1143000"/>
+            <a:off x="731520" y="1097280"/>
             <a:ext cx="10725912" cy="0"/>
           </a:xfrm>
           <a:prstGeom prst="line">
@@ -4251,7 +4251,7 @@
         <p:spPr>
           <a:xfrm>
             <a:off x="731520" y="365760"/>
-            <a:ext cx="10698480" cy="731520"/>
+            <a:ext cx="10725912" cy="640080"/>
           </a:xfrm>
           <a:prstGeom prst="rect">
             <a:avLst/>
@@ -4289,7 +4289,7 @@
         </p:nvSpPr>
         <p:spPr>
           <a:xfrm>
-            <a:off x="731520" y="1143000"/>
+            <a:off x="731520" y="1097280"/>
             <a:ext cx="10725912" cy="0"/>
           </a:xfrm>
           <a:prstGeom prst="line">
@@ -5961,7 +5961,7 @@
         <p:spPr>
           <a:xfrm>
             <a:off x="731520" y="365760"/>
-            <a:ext cx="10698480" cy="731520"/>
+            <a:ext cx="10725912" cy="640080"/>
           </a:xfrm>
           <a:prstGeom prst="rect">
             <a:avLst/>
@@ -5999,7 +5999,7 @@
         </p:nvSpPr>
         <p:spPr>
           <a:xfrm>
-            <a:off x="731520" y="1143000"/>
+            <a:off x="731520" y="1097280"/>
             <a:ext cx="10725912" cy="0"/>
           </a:xfrm>
           <a:prstGeom prst="line">
@@ -6432,7 +6432,7 @@
         <p:spPr>
           <a:xfrm>
             <a:off x="731520" y="365760"/>
-            <a:ext cx="10698480" cy="731520"/>
+            <a:ext cx="10725912" cy="640080"/>
           </a:xfrm>
           <a:prstGeom prst="rect">
             <a:avLst/>
@@ -6470,7 +6470,7 @@
         </p:nvSpPr>
         <p:spPr>
           <a:xfrm>
-            <a:off x="731520" y="1143000"/>
+            <a:off x="731520" y="1097280"/>
             <a:ext cx="10725912" cy="0"/>
           </a:xfrm>
           <a:prstGeom prst="line">
@@ -6952,7 +6952,7 @@
         <p:spPr>
           <a:xfrm>
             <a:off x="731520" y="365760"/>
-            <a:ext cx="10698480" cy="731520"/>
+            <a:ext cx="10725912" cy="640080"/>
           </a:xfrm>
           <a:prstGeom prst="rect">
             <a:avLst/>
@@ -6990,7 +6990,7 @@
         </p:nvSpPr>
         <p:spPr>
           <a:xfrm>
-            <a:off x="731520" y="1143000"/>
+            <a:off x="731520" y="1097280"/>
             <a:ext cx="10725912" cy="0"/>
           </a:xfrm>
           <a:prstGeom prst="line">
@@ -7423,7 +7423,7 @@
         <p:spPr>
           <a:xfrm>
             <a:off x="731520" y="365760"/>
-            <a:ext cx="10698480" cy="731520"/>
+            <a:ext cx="10725912" cy="640080"/>
           </a:xfrm>
           <a:prstGeom prst="rect">
             <a:avLst/>
@@ -7461,7 +7461,7 @@
         </p:nvSpPr>
         <p:spPr>
           <a:xfrm>
-            <a:off x="731520" y="1143000"/>
+            <a:off x="731520" y="1097280"/>
             <a:ext cx="10725912" cy="0"/>
           </a:xfrm>
           <a:prstGeom prst="line">

</xml_diff>

<commit_message>
Final commit: update gitignore and presentation script
</commit_message>
<xml_diff>
--- a/EventEase_Presentation.pptx
+++ b/EventEase_Presentation.pptx
@@ -1658,7 +1658,7 @@
     <p:bg>
       <p:bgPr>
         <a:solidFill>
-          <a:srgbClr val="0F172A"/>
+          <a:srgbClr val="FFFFFF"/>
         </a:solidFill>
       </p:bgPr>
     </p:bg>
@@ -1684,18 +1684,18 @@
         </p:nvSpPr>
         <p:spPr>
           <a:xfrm>
-            <a:off x="4389120" y="731520"/>
-            <a:ext cx="3383280" cy="457200"/>
+            <a:off x="4206240" y="731520"/>
+            <a:ext cx="3749040" cy="457200"/>
           </a:xfrm>
           <a:prstGeom prst="roundRect">
             <a:avLst/>
           </a:prstGeom>
           <a:solidFill>
-            <a:srgbClr val="1E40AF"/>
+            <a:srgbClr val="DBEAFE"/>
           </a:solidFill>
           <a:ln w="12700">
             <a:solidFill>
-              <a:srgbClr val="3B82F6"/>
+              <a:srgbClr val="1E40AF"/>
             </a:solidFill>
             <a:prstDash val="solid"/>
           </a:ln>
@@ -1709,8 +1709,8 @@
         </p:nvSpPr>
         <p:spPr>
           <a:xfrm>
-            <a:off x="4389120" y="731520"/>
-            <a:ext cx="3383280" cy="457200"/>
+            <a:off x="4206240" y="731520"/>
+            <a:ext cx="3749040" cy="457200"/>
           </a:xfrm>
           <a:prstGeom prst="rect">
             <a:avLst/>
@@ -1728,7 +1728,7 @@
             <a:r>
               <a:rPr lang="en-US" sz="1400" b="1" dirty="0">
                 <a:solidFill>
-                  <a:srgbClr val="FFFFFF"/>
+                  <a:srgbClr val="1E40AF"/>
                 </a:solidFill>
                 <a:latin typeface="Segoe UI" pitchFamily="34" charset="0"/>
                 <a:ea typeface="Segoe UI" pitchFamily="34" charset="-122"/>
@@ -1767,7 +1767,7 @@
             <a:r>
               <a:rPr lang="en-US" sz="5600" b="1" dirty="0">
                 <a:solidFill>
-                  <a:srgbClr val="FFFFFF"/>
+                  <a:srgbClr val="0F172A"/>
                 </a:solidFill>
                 <a:latin typeface="Segoe UI" pitchFamily="34" charset="0"/>
                 <a:ea typeface="Segoe UI" pitchFamily="34" charset="-122"/>
@@ -1806,7 +1806,7 @@
             <a:r>
               <a:rPr lang="en-US" sz="2400" b="1" dirty="0">
                 <a:solidFill>
-                  <a:srgbClr val="60A5FA"/>
+                  <a:srgbClr val="2563EB"/>
                 </a:solidFill>
                 <a:latin typeface="Segoe UI" pitchFamily="34" charset="0"/>
                 <a:ea typeface="Segoe UI" pitchFamily="34" charset="-122"/>
@@ -1845,13 +1845,13 @@
             <a:r>
               <a:rPr lang="en-US" sz="1600" dirty="0">
                 <a:solidFill>
-                  <a:srgbClr val="94A3B8"/>
-                </a:solidFill>
-                <a:latin typeface="Segoe UI" pitchFamily="34" charset="0"/>
-                <a:ea typeface="Segoe UI" pitchFamily="34" charset="-122"/>
-                <a:cs typeface="Segoe UI" pitchFamily="34" charset="-120"/>
-              </a:rPr>
-              <a:t>Built with ASP.NET MVC, C#, Bootstrap 5 &amp; User Management</a:t>
+                  <a:srgbClr val="475569"/>
+                </a:solidFill>
+                <a:latin typeface="Segoe UI" pitchFamily="34" charset="0"/>
+                <a:ea typeface="Segoe UI" pitchFamily="34" charset="-122"/>
+                <a:cs typeface="Segoe UI" pitchFamily="34" charset="-120"/>
+              </a:rPr>
+              <a:t>Developed with ASP.NET MVC, C#, Bootstrap 5 &amp; User Management</a:t>
             </a:r>
             <a:endParaRPr lang="en-US" sz="1600" dirty="0"/>
           </a:p>
@@ -1872,11 +1872,11 @@
             <a:avLst/>
           </a:prstGeom>
           <a:solidFill>
-            <a:srgbClr val="1E293B"/>
+            <a:srgbClr val="F8FAFC"/>
           </a:solidFill>
-          <a:ln w="25400">
+          <a:ln w="19050">
             <a:solidFill>
-              <a:srgbClr val="3B82F6"/>
+              <a:srgbClr val="CBD5E1"/>
             </a:solidFill>
             <a:prstDash val="solid"/>
           </a:ln>
@@ -1909,7 +1909,7 @@
             <a:r>
               <a:rPr lang="en-US" sz="1500" b="1" dirty="0">
                 <a:solidFill>
-                  <a:srgbClr val="FFFFFF"/>
+                  <a:srgbClr val="0F172A"/>
                 </a:solidFill>
                 <a:latin typeface="Segoe UI" pitchFamily="34" charset="0"/>
                 <a:ea typeface="Segoe UI" pitchFamily="34" charset="-122"/>
@@ -1923,7 +1923,7 @@
             <a:r>
               <a:rPr lang="en-US" sz="1500" dirty="0">
                 <a:solidFill>
-                  <a:srgbClr val="60A5FA"/>
+                  <a:srgbClr val="1E40AF"/>
                 </a:solidFill>
                 <a:latin typeface="Segoe UI" pitchFamily="34" charset="0"/>
                 <a:ea typeface="Segoe UI" pitchFamily="34" charset="-122"/>
@@ -1938,13 +1938,13 @@
             <a:r>
               <a:rPr lang="en-US" sz="1500" b="1" dirty="0">
                 <a:solidFill>
-                  <a:srgbClr val="FFFFFF"/>
-                </a:solidFill>
-                <a:latin typeface="Segoe UI" pitchFamily="34" charset="0"/>
-                <a:ea typeface="Segoe UI" pitchFamily="34" charset="-122"/>
-                <a:cs typeface="Segoe UI" pitchFamily="34" charset="-120"/>
-              </a:rPr>
-              <a:t>Technology: </a:t>
+                  <a:srgbClr val="0F172A"/>
+                </a:solidFill>
+                <a:latin typeface="Segoe UI" pitchFamily="34" charset="0"/>
+                <a:ea typeface="Segoe UI" pitchFamily="34" charset="-122"/>
+                <a:cs typeface="Segoe UI" pitchFamily="34" charset="-120"/>
+              </a:rPr>
+              <a:t>Technology Stack: </a:t>
             </a:r>
             <a:pPr indent="0" marL="0">
               <a:buNone/>
@@ -1952,7 +1952,7 @@
             <a:r>
               <a:rPr lang="en-US" sz="1500" dirty="0">
                 <a:solidFill>
-                  <a:srgbClr val="60A5FA"/>
+                  <a:srgbClr val="1E40AF"/>
                 </a:solidFill>
                 <a:latin typeface="Segoe UI" pitchFamily="34" charset="0"/>
                 <a:ea typeface="Segoe UI" pitchFamily="34" charset="-122"/>
@@ -1967,13 +1967,13 @@
             <a:r>
               <a:rPr lang="en-US" sz="1500" b="1" dirty="0">
                 <a:solidFill>
-                  <a:srgbClr val="FFFFFF"/>
-                </a:solidFill>
-                <a:latin typeface="Segoe UI" pitchFamily="34" charset="0"/>
-                <a:ea typeface="Segoe UI" pitchFamily="34" charset="-122"/>
-                <a:cs typeface="Segoe UI" pitchFamily="34" charset="-120"/>
-              </a:rPr>
-              <a:t>Currency: </a:t>
+                  <a:srgbClr val="0F172A"/>
+                </a:solidFill>
+                <a:latin typeface="Segoe UI" pitchFamily="34" charset="0"/>
+                <a:ea typeface="Segoe UI" pitchFamily="34" charset="-122"/>
+                <a:cs typeface="Segoe UI" pitchFamily="34" charset="-120"/>
+              </a:rPr>
+              <a:t>Currency Format: </a:t>
             </a:r>
             <a:pPr indent="0" marL="0">
               <a:buNone/>
@@ -1981,7 +1981,7 @@
             <a:r>
               <a:rPr lang="en-US" sz="1500" dirty="0">
                 <a:solidFill>
-                  <a:srgbClr val="10B981"/>
+                  <a:srgbClr val="059669"/>
                 </a:solidFill>
                 <a:latin typeface="Segoe UI" pitchFamily="34" charset="0"/>
                 <a:ea typeface="Segoe UI" pitchFamily="34" charset="-122"/>
@@ -2008,11 +2008,11 @@
             <a:avLst/>
           </a:prstGeom>
           <a:solidFill>
-            <a:srgbClr val="1E293B"/>
+            <a:srgbClr val="F8FAFC"/>
           </a:solidFill>
-          <a:ln w="25400">
+          <a:ln w="19050">
             <a:solidFill>
-              <a:srgbClr val="10B981"/>
+              <a:srgbClr val="CBD5E1"/>
             </a:solidFill>
             <a:prstDash val="solid"/>
           </a:ln>
@@ -2045,13 +2045,13 @@
             <a:r>
               <a:rPr lang="en-US" sz="1500" b="1" dirty="0">
                 <a:solidFill>
-                  <a:srgbClr val="FFFFFF"/>
-                </a:solidFill>
-                <a:latin typeface="Segoe UI" pitchFamily="34" charset="0"/>
-                <a:ea typeface="Segoe UI" pitchFamily="34" charset="-122"/>
-                <a:cs typeface="Segoe UI" pitchFamily="34" charset="-120"/>
-              </a:rPr>
-              <a:t>Repository: </a:t>
+                  <a:srgbClr val="0F172A"/>
+                </a:solidFill>
+                <a:latin typeface="Segoe UI" pitchFamily="34" charset="0"/>
+                <a:ea typeface="Segoe UI" pitchFamily="34" charset="-122"/>
+                <a:cs typeface="Segoe UI" pitchFamily="34" charset="-120"/>
+              </a:rPr>
+              <a:t>Version Control: </a:t>
             </a:r>
             <a:pPr indent="0" marL="0">
               <a:buNone/>
@@ -2059,7 +2059,7 @@
             <a:r>
               <a:rPr lang="en-US" sz="1500" dirty="0">
                 <a:solidFill>
-                  <a:srgbClr val="60A5FA"/>
+                  <a:srgbClr val="1E40AF"/>
                 </a:solidFill>
                 <a:latin typeface="Segoe UI" pitchFamily="34" charset="0"/>
                 <a:ea typeface="Segoe UI" pitchFamily="34" charset="-122"/>
@@ -2074,7 +2074,7 @@
             <a:r>
               <a:rPr lang="en-US" sz="1500" b="1" dirty="0">
                 <a:solidFill>
-                  <a:srgbClr val="FFFFFF"/>
+                  <a:srgbClr val="0F172A"/>
                 </a:solidFill>
                 <a:latin typeface="Segoe UI" pitchFamily="34" charset="0"/>
                 <a:ea typeface="Segoe UI" pitchFamily="34" charset="-122"/>
@@ -2088,7 +2088,7 @@
             <a:r>
               <a:rPr lang="en-US" sz="1500" dirty="0">
                 <a:solidFill>
-                  <a:srgbClr val="60A5FA"/>
+                  <a:srgbClr val="1E40AF"/>
                 </a:solidFill>
                 <a:latin typeface="Segoe UI" pitchFamily="34" charset="0"/>
                 <a:ea typeface="Segoe UI" pitchFamily="34" charset="-122"/>
@@ -2103,7 +2103,7 @@
             <a:r>
               <a:rPr lang="en-US" sz="1500" b="1" dirty="0">
                 <a:solidFill>
-                  <a:srgbClr val="FFFFFF"/>
+                  <a:srgbClr val="0F172A"/>
                 </a:solidFill>
                 <a:latin typeface="Segoe UI" pitchFamily="34" charset="0"/>
                 <a:ea typeface="Segoe UI" pitchFamily="34" charset="-122"/>
@@ -2117,7 +2117,7 @@
             <a:r>
               <a:rPr lang="en-US" sz="1500" dirty="0">
                 <a:solidFill>
-                  <a:srgbClr val="10B981"/>
+                  <a:srgbClr val="059669"/>
                 </a:solidFill>
                 <a:latin typeface="Segoe UI" pitchFamily="34" charset="0"/>
                 <a:ea typeface="Segoe UI" pitchFamily="34" charset="-122"/>
@@ -2143,7 +2143,7 @@
     <p:bg>
       <p:bgPr>
         <a:solidFill>
-          <a:srgbClr val="0F172A"/>
+          <a:srgbClr val="FFFFFF"/>
         </a:solidFill>
       </p:bgPr>
     </p:bg>
@@ -2188,7 +2188,7 @@
             <a:r>
               <a:rPr lang="en-US" sz="5600" b="1" dirty="0">
                 <a:solidFill>
-                  <a:srgbClr val="FFFFFF"/>
+                  <a:srgbClr val="0F172A"/>
                 </a:solidFill>
                 <a:latin typeface="Segoe UI" pitchFamily="34" charset="0"/>
                 <a:ea typeface="Segoe UI" pitchFamily="34" charset="-122"/>
@@ -2227,7 +2227,7 @@
             <a:r>
               <a:rPr lang="en-US" sz="2400" b="1" dirty="0">
                 <a:solidFill>
-                  <a:srgbClr val="60A5FA"/>
+                  <a:srgbClr val="1E40AF"/>
                 </a:solidFill>
                 <a:latin typeface="Segoe UI" pitchFamily="34" charset="0"/>
                 <a:ea typeface="Segoe UI" pitchFamily="34" charset="-122"/>
@@ -2254,11 +2254,11 @@
             <a:avLst/>
           </a:prstGeom>
           <a:solidFill>
-            <a:srgbClr val="1E293B"/>
+            <a:srgbClr val="F8FAFC"/>
           </a:solidFill>
           <a:ln w="25400">
             <a:solidFill>
-              <a:srgbClr val="10B981"/>
+              <a:srgbClr val="059669"/>
             </a:solidFill>
             <a:prstDash val="solid"/>
           </a:ln>
@@ -2291,7 +2291,7 @@
             <a:r>
               <a:rPr lang="en-US" sz="1600" dirty="0">
                 <a:solidFill>
-                  <a:srgbClr val="FFFFFF"/>
+                  <a:srgbClr val="0F172A"/>
                 </a:solidFill>
                 <a:latin typeface="Segoe UI" pitchFamily="34" charset="0"/>
                 <a:ea typeface="Segoe UI" pitchFamily="34" charset="-122"/>
@@ -2308,7 +2308,7 @@
             <a:r>
               <a:rPr lang="en-US" sz="1600" dirty="0">
                 <a:solidFill>
-                  <a:srgbClr val="FFFFFF"/>
+                  <a:srgbClr val="0F172A"/>
                 </a:solidFill>
                 <a:latin typeface="Segoe UI" pitchFamily="34" charset="0"/>
                 <a:ea typeface="Segoe UI" pitchFamily="34" charset="-122"/>
@@ -2325,7 +2325,7 @@
             <a:r>
               <a:rPr lang="en-US" sz="1600" dirty="0">
                 <a:solidFill>
-                  <a:srgbClr val="FFFFFF"/>
+                  <a:srgbClr val="0F172A"/>
                 </a:solidFill>
                 <a:latin typeface="Segoe UI" pitchFamily="34" charset="0"/>
                 <a:ea typeface="Segoe UI" pitchFamily="34" charset="-122"/>
@@ -2342,7 +2342,7 @@
             <a:r>
               <a:rPr lang="en-US" sz="1600" dirty="0">
                 <a:solidFill>
-                  <a:srgbClr val="FFFFFF"/>
+                  <a:srgbClr val="0F172A"/>
                 </a:solidFill>
                 <a:latin typeface="Segoe UI" pitchFamily="34" charset="0"/>
                 <a:ea typeface="Segoe UI" pitchFamily="34" charset="-122"/>
@@ -2359,7 +2359,7 @@
             <a:r>
               <a:rPr lang="en-US" sz="1600" dirty="0">
                 <a:solidFill>
-                  <a:srgbClr val="FFFFFF"/>
+                  <a:srgbClr val="0F172A"/>
                 </a:solidFill>
                 <a:latin typeface="Segoe UI" pitchFamily="34" charset="0"/>
                 <a:ea typeface="Segoe UI" pitchFamily="34" charset="-122"/>
@@ -2385,7 +2385,7 @@
     <p:bg>
       <p:bgPr>
         <a:solidFill>
-          <a:srgbClr val="0F172A"/>
+          <a:srgbClr val="FFFFFF"/>
         </a:solidFill>
       </p:bgPr>
     </p:bg>
@@ -2430,7 +2430,7 @@
             <a:r>
               <a:rPr lang="en-US" sz="2600" b="1" dirty="0">
                 <a:solidFill>
-                  <a:srgbClr val="60A5FA"/>
+                  <a:srgbClr val="1E40AF"/>
                 </a:solidFill>
                 <a:latin typeface="Segoe UI" pitchFamily="34" charset="0"/>
                 <a:ea typeface="Segoe UI" pitchFamily="34" charset="-122"/>
@@ -2459,7 +2459,7 @@
           <a:noFill/>
           <a:ln w="25400">
             <a:solidFill>
-              <a:srgbClr val="334155"/>
+              <a:srgbClr val="E2E8F0"/>
             </a:solidFill>
             <a:prstDash val="solid"/>
           </a:ln>
@@ -2480,11 +2480,11 @@
             <a:avLst/>
           </a:prstGeom>
           <a:solidFill>
-            <a:srgbClr val="1E293B"/>
+            <a:srgbClr val="FEF2F2"/>
           </a:solidFill>
-          <a:ln w="25400">
+          <a:ln w="19050">
             <a:solidFill>
-              <a:srgbClr val="EF4444"/>
+              <a:srgbClr val="FECACA"/>
             </a:solidFill>
             <a:prstDash val="solid"/>
           </a:ln>
@@ -2517,13 +2517,13 @@
             <a:r>
               <a:rPr lang="en-US" sz="2000" b="1" dirty="0">
                 <a:solidFill>
-                  <a:srgbClr val="EF4444"/>
-                </a:solidFill>
-                <a:latin typeface="Segoe UI" pitchFamily="34" charset="0"/>
-                <a:ea typeface="Segoe UI" pitchFamily="34" charset="-122"/>
-                <a:cs typeface="Segoe UI" pitchFamily="34" charset="-120"/>
-              </a:rPr>
-              <a:t>The Problem Statement</a:t>
+                  <a:srgbClr val="DC2626"/>
+                </a:solidFill>
+                <a:latin typeface="Segoe UI" pitchFamily="34" charset="0"/>
+                <a:ea typeface="Segoe UI" pitchFamily="34" charset="-122"/>
+                <a:cs typeface="Segoe UI" pitchFamily="34" charset="-120"/>
+              </a:rPr>
+              <a:t>Problem Statement</a:t>
             </a:r>
             <a:endParaRPr lang="en-US" sz="2000" dirty="0"/>
           </a:p>
@@ -2556,13 +2556,13 @@
             <a:r>
               <a:rPr lang="en-US" sz="1400" b="1" dirty="0">
                 <a:solidFill>
-                  <a:srgbClr val="FFFFFF"/>
-                </a:solidFill>
-                <a:latin typeface="Segoe UI" pitchFamily="34" charset="0"/>
-                <a:ea typeface="Segoe UI" pitchFamily="34" charset="-122"/>
-                <a:cs typeface="Segoe UI" pitchFamily="34" charset="-120"/>
-              </a:rPr>
-              <a:t>• Long Physical Queues: </a:t>
+                  <a:srgbClr val="0F172A"/>
+                </a:solidFill>
+                <a:latin typeface="Segoe UI" pitchFamily="34" charset="0"/>
+                <a:ea typeface="Segoe UI" pitchFamily="34" charset="-122"/>
+                <a:cs typeface="Segoe UI" pitchFamily="34" charset="-120"/>
+              </a:rPr>
+              <a:t>• Physical Queues: </a:t>
             </a:r>
             <a:pPr indent="0" marL="0">
               <a:buNone/>
@@ -2570,13 +2570,13 @@
             <a:r>
               <a:rPr lang="en-US" sz="1400" dirty="0">
                 <a:solidFill>
-                  <a:srgbClr val="CBD5E1"/>
-                </a:solidFill>
-                <a:latin typeface="Segoe UI" pitchFamily="34" charset="0"/>
-                <a:ea typeface="Segoe UI" pitchFamily="34" charset="-122"/>
-                <a:cs typeface="Segoe UI" pitchFamily="34" charset="-120"/>
-              </a:rPr>
-              <a:t>Traditional ticket counters suffer from long waiting times and physical bottlenecks.
+                  <a:srgbClr val="475569"/>
+                </a:solidFill>
+                <a:latin typeface="Segoe UI" pitchFamily="34" charset="0"/>
+                <a:ea typeface="Segoe UI" pitchFamily="34" charset="-122"/>
+                <a:cs typeface="Segoe UI" pitchFamily="34" charset="-120"/>
+              </a:rPr>
+              <a:t>Physical ticket counters suffer from long waiting times and congestion.
 </a:t>
             </a:r>
             <a:pPr indent="0" marL="0">
@@ -2585,13 +2585,13 @@
             <a:r>
               <a:rPr lang="en-US" sz="1400" b="1" dirty="0">
                 <a:solidFill>
-                  <a:srgbClr val="FFFFFF"/>
-                </a:solidFill>
-                <a:latin typeface="Segoe UI" pitchFamily="34" charset="0"/>
-                <a:ea typeface="Segoe UI" pitchFamily="34" charset="-122"/>
-                <a:cs typeface="Segoe UI" pitchFamily="34" charset="-120"/>
-              </a:rPr>
-              <a:t>• Fragmented Event Discovery: </a:t>
+                  <a:srgbClr val="0F172A"/>
+                </a:solidFill>
+                <a:latin typeface="Segoe UI" pitchFamily="34" charset="0"/>
+                <a:ea typeface="Segoe UI" pitchFamily="34" charset="-122"/>
+                <a:cs typeface="Segoe UI" pitchFamily="34" charset="-120"/>
+              </a:rPr>
+              <a:t>• Scattered Information: </a:t>
             </a:r>
             <a:pPr indent="0" marL="0">
               <a:buNone/>
@@ -2599,13 +2599,13 @@
             <a:r>
               <a:rPr lang="en-US" sz="1400" dirty="0">
                 <a:solidFill>
-                  <a:srgbClr val="CBD5E1"/>
-                </a:solidFill>
-                <a:latin typeface="Segoe UI" pitchFamily="34" charset="0"/>
-                <a:ea typeface="Segoe UI" pitchFamily="34" charset="-122"/>
-                <a:cs typeface="Segoe UI" pitchFamily="34" charset="-120"/>
-              </a:rPr>
-              <a:t>Attendees lack a single portal to explore concerts, summits, and workshops.
+                  <a:srgbClr val="475569"/>
+                </a:solidFill>
+                <a:latin typeface="Segoe UI" pitchFamily="34" charset="0"/>
+                <a:ea typeface="Segoe UI" pitchFamily="34" charset="-122"/>
+                <a:cs typeface="Segoe UI" pitchFamily="34" charset="-120"/>
+              </a:rPr>
+              <a:t>Lack of a single platform to discover local concerts, summits, and workshops.
 </a:t>
             </a:r>
             <a:pPr indent="0" marL="0">
@@ -2614,13 +2614,13 @@
             <a:r>
               <a:rPr lang="en-US" sz="1400" b="1" dirty="0">
                 <a:solidFill>
-                  <a:srgbClr val="FFFFFF"/>
-                </a:solidFill>
-                <a:latin typeface="Segoe UI" pitchFamily="34" charset="0"/>
-                <a:ea typeface="Segoe UI" pitchFamily="34" charset="-122"/>
-                <a:cs typeface="Segoe UI" pitchFamily="34" charset="-120"/>
-              </a:rPr>
-              <a:t>• Ticket Misplacement: </a:t>
+                  <a:srgbClr val="0F172A"/>
+                </a:solidFill>
+                <a:latin typeface="Segoe UI" pitchFamily="34" charset="0"/>
+                <a:ea typeface="Segoe UI" pitchFamily="34" charset="-122"/>
+                <a:cs typeface="Segoe UI" pitchFamily="34" charset="-120"/>
+              </a:rPr>
+              <a:t>• Paper Ticket Loss: </a:t>
             </a:r>
             <a:pPr indent="0" marL="0">
               <a:buNone/>
@@ -2628,13 +2628,13 @@
             <a:r>
               <a:rPr lang="en-US" sz="1400" dirty="0">
                 <a:solidFill>
-                  <a:srgbClr val="CBD5E1"/>
-                </a:solidFill>
-                <a:latin typeface="Segoe UI" pitchFamily="34" charset="0"/>
-                <a:ea typeface="Segoe UI" pitchFamily="34" charset="-122"/>
-                <a:cs typeface="Segoe UI" pitchFamily="34" charset="-120"/>
-              </a:rPr>
-              <a:t>Paper tickets get lost easily without digital account backups.</a:t>
+                  <a:srgbClr val="475569"/>
+                </a:solidFill>
+                <a:latin typeface="Segoe UI" pitchFamily="34" charset="0"/>
+                <a:ea typeface="Segoe UI" pitchFamily="34" charset="-122"/>
+                <a:cs typeface="Segoe UI" pitchFamily="34" charset="-120"/>
+              </a:rPr>
+              <a:t>Paper tickets get misplaced easily without digital account backups.</a:t>
             </a:r>
             <a:endParaRPr lang="en-US" sz="1400" dirty="0"/>
           </a:p>
@@ -2655,11 +2655,11 @@
             <a:avLst/>
           </a:prstGeom>
           <a:solidFill>
-            <a:srgbClr val="1E293B"/>
+            <a:srgbClr val="ECFDF5"/>
           </a:solidFill>
-          <a:ln w="25400">
+          <a:ln w="19050">
             <a:solidFill>
-              <a:srgbClr val="10B981"/>
+              <a:srgbClr val="A7F3D0"/>
             </a:solidFill>
             <a:prstDash val="solid"/>
           </a:ln>
@@ -2692,13 +2692,13 @@
             <a:r>
               <a:rPr lang="en-US" sz="2000" b="1" dirty="0">
                 <a:solidFill>
-                  <a:srgbClr val="10B981"/>
-                </a:solidFill>
-                <a:latin typeface="Segoe UI" pitchFamily="34" charset="0"/>
-                <a:ea typeface="Segoe UI" pitchFamily="34" charset="-122"/>
-                <a:cs typeface="Segoe UI" pitchFamily="34" charset="-120"/>
-              </a:rPr>
-              <a:t>The EventEase Solution</a:t>
+                  <a:srgbClr val="059669"/>
+                </a:solidFill>
+                <a:latin typeface="Segoe UI" pitchFamily="34" charset="0"/>
+                <a:ea typeface="Segoe UI" pitchFamily="34" charset="-122"/>
+                <a:cs typeface="Segoe UI" pitchFamily="34" charset="-120"/>
+              </a:rPr>
+              <a:t>EventEase Solution</a:t>
             </a:r>
             <a:endParaRPr lang="en-US" sz="2000" dirty="0"/>
           </a:p>
@@ -2731,13 +2731,13 @@
             <a:r>
               <a:rPr lang="en-US" sz="1400" b="1" dirty="0">
                 <a:solidFill>
-                  <a:srgbClr val="FFFFFF"/>
-                </a:solidFill>
-                <a:latin typeface="Segoe UI" pitchFamily="34" charset="0"/>
-                <a:ea typeface="Segoe UI" pitchFamily="34" charset="-122"/>
-                <a:cs typeface="Segoe UI" pitchFamily="34" charset="-120"/>
-              </a:rPr>
-              <a:t>• Instant 24/7 Booking: </a:t>
+                  <a:srgbClr val="0F172A"/>
+                </a:solidFill>
+                <a:latin typeface="Segoe UI" pitchFamily="34" charset="0"/>
+                <a:ea typeface="Segoe UI" pitchFamily="34" charset="-122"/>
+                <a:cs typeface="Segoe UI" pitchFamily="34" charset="-120"/>
+              </a:rPr>
+              <a:t>• 24/7 Web Portal: </a:t>
             </a:r>
             <a:pPr indent="0" marL="0">
               <a:buNone/>
@@ -2745,13 +2745,13 @@
             <a:r>
               <a:rPr lang="en-US" sz="1400" dirty="0">
                 <a:solidFill>
-                  <a:srgbClr val="CBD5E1"/>
-                </a:solidFill>
-                <a:latin typeface="Segoe UI" pitchFamily="34" charset="0"/>
-                <a:ea typeface="Segoe UI" pitchFamily="34" charset="-122"/>
-                <a:cs typeface="Segoe UI" pitchFamily="34" charset="-120"/>
-              </a:rPr>
-              <a:t>Centralized Web Application allowing ticket reservation from anywhere.
+                  <a:srgbClr val="475569"/>
+                </a:solidFill>
+                <a:latin typeface="Segoe UI" pitchFamily="34" charset="0"/>
+                <a:ea typeface="Segoe UI" pitchFamily="34" charset="-122"/>
+                <a:cs typeface="Segoe UI" pitchFamily="34" charset="-120"/>
+              </a:rPr>
+              <a:t>Centralized ASP.NET MVC web application for instant online reservation.
 </a:t>
             </a:r>
             <a:pPr indent="0" marL="0">
@@ -2760,13 +2760,13 @@
             <a:r>
               <a:rPr lang="en-US" sz="1400" b="1" dirty="0">
                 <a:solidFill>
-                  <a:srgbClr val="FFFFFF"/>
-                </a:solidFill>
-                <a:latin typeface="Segoe UI" pitchFamily="34" charset="0"/>
-                <a:ea typeface="Segoe UI" pitchFamily="34" charset="-122"/>
-                <a:cs typeface="Segoe UI" pitchFamily="34" charset="-120"/>
-              </a:rPr>
-              <a:t>• Automatic Rupee Pricing: </a:t>
+                  <a:srgbClr val="0F172A"/>
+                </a:solidFill>
+                <a:latin typeface="Segoe UI" pitchFamily="34" charset="0"/>
+                <a:ea typeface="Segoe UI" pitchFamily="34" charset="-122"/>
+                <a:cs typeface="Segoe UI" pitchFamily="34" charset="-120"/>
+              </a:rPr>
+              <a:t>• Rupee Pricing: </a:t>
             </a:r>
             <a:pPr indent="0" marL="0">
               <a:buNone/>
@@ -2774,13 +2774,13 @@
             <a:r>
               <a:rPr lang="en-US" sz="1400" dirty="0">
                 <a:solidFill>
-                  <a:srgbClr val="CBD5E1"/>
-                </a:solidFill>
-                <a:latin typeface="Segoe UI" pitchFamily="34" charset="0"/>
-                <a:ea typeface="Segoe UI" pitchFamily="34" charset="-122"/>
-                <a:cs typeface="Segoe UI" pitchFamily="34" charset="-120"/>
-              </a:rPr>
-              <a:t>Instant price calculations natively in Indian Rupees (₹).
+                  <a:srgbClr val="475569"/>
+                </a:solidFill>
+                <a:latin typeface="Segoe UI" pitchFamily="34" charset="0"/>
+                <a:ea typeface="Segoe UI" pitchFamily="34" charset="-122"/>
+                <a:cs typeface="Segoe UI" pitchFamily="34" charset="-120"/>
+              </a:rPr>
+              <a:t>Instant automated price calculations natively in Indian Rupees (₹).
 </a:t>
             </a:r>
             <a:pPr indent="0" marL="0">
@@ -2789,7 +2789,7 @@
             <a:r>
               <a:rPr lang="en-US" sz="1400" b="1" dirty="0">
                 <a:solidFill>
-                  <a:srgbClr val="FFFFFF"/>
+                  <a:srgbClr val="0F172A"/>
                 </a:solidFill>
                 <a:latin typeface="Segoe UI" pitchFamily="34" charset="0"/>
                 <a:ea typeface="Segoe UI" pitchFamily="34" charset="-122"/>
@@ -2803,13 +2803,13 @@
             <a:r>
               <a:rPr lang="en-US" sz="1400" dirty="0">
                 <a:solidFill>
-                  <a:srgbClr val="CBD5E1"/>
-                </a:solidFill>
-                <a:latin typeface="Segoe UI" pitchFamily="34" charset="0"/>
-                <a:ea typeface="Segoe UI" pitchFamily="34" charset="-122"/>
-                <a:cs typeface="Segoe UI" pitchFamily="34" charset="-120"/>
-              </a:rPr>
-              <a:t>All booked passes are saved directly to the user's Profile Dashboard.</a:t>
+                  <a:srgbClr val="475569"/>
+                </a:solidFill>
+                <a:latin typeface="Segoe UI" pitchFamily="34" charset="0"/>
+                <a:ea typeface="Segoe UI" pitchFamily="34" charset="-122"/>
+                <a:cs typeface="Segoe UI" pitchFamily="34" charset="-120"/>
+              </a:rPr>
+              <a:t>Booked tickets are saved directly to the user's Profile Dashboard.</a:t>
             </a:r>
             <a:endParaRPr lang="en-US" sz="1400" dirty="0"/>
           </a:p>
@@ -2829,7 +2829,7 @@
     <p:bg>
       <p:bgPr>
         <a:solidFill>
-          <a:srgbClr val="0F172A"/>
+          <a:srgbClr val="FFFFFF"/>
         </a:solidFill>
       </p:bgPr>
     </p:bg>
@@ -2874,7 +2874,7 @@
             <a:r>
               <a:rPr lang="en-US" sz="2600" b="1" dirty="0">
                 <a:solidFill>
-                  <a:srgbClr val="60A5FA"/>
+                  <a:srgbClr val="1E40AF"/>
                 </a:solidFill>
                 <a:latin typeface="Segoe UI" pitchFamily="34" charset="0"/>
                 <a:ea typeface="Segoe UI" pitchFamily="34" charset="-122"/>
@@ -2903,7 +2903,7 @@
           <a:noFill/>
           <a:ln w="25400">
             <a:solidFill>
-              <a:srgbClr val="334155"/>
+              <a:srgbClr val="E2E8F0"/>
             </a:solidFill>
             <a:prstDash val="solid"/>
           </a:ln>
@@ -2924,11 +2924,11 @@
             <a:avLst/>
           </a:prstGeom>
           <a:solidFill>
-            <a:srgbClr val="1E293B"/>
+            <a:srgbClr val="F8FAFC"/>
           </a:solidFill>
-          <a:ln w="25400">
+          <a:ln w="19050">
             <a:solidFill>
-              <a:srgbClr val="3B82F6"/>
+              <a:srgbClr val="CBD5E1"/>
             </a:solidFill>
             <a:prstDash val="solid"/>
           </a:ln>
@@ -2961,7 +2961,7 @@
             <a:r>
               <a:rPr lang="en-US" sz="1800" b="1" dirty="0">
                 <a:solidFill>
-                  <a:srgbClr val="3B82F6"/>
+                  <a:srgbClr val="1E40AF"/>
                 </a:solidFill>
                 <a:latin typeface="Segoe UI" pitchFamily="34" charset="0"/>
                 <a:ea typeface="Segoe UI" pitchFamily="34" charset="-122"/>
@@ -3000,7 +3000,7 @@
             <a:r>
               <a:rPr lang="en-US" sz="1300" dirty="0">
                 <a:solidFill>
-                  <a:srgbClr val="CBD5E1"/>
+                  <a:srgbClr val="475569"/>
                 </a:solidFill>
                 <a:latin typeface="Segoe UI" pitchFamily="34" charset="0"/>
                 <a:ea typeface="Segoe UI" pitchFamily="34" charset="-122"/>
@@ -3027,11 +3027,11 @@
             <a:avLst/>
           </a:prstGeom>
           <a:solidFill>
-            <a:srgbClr val="1E293B"/>
+            <a:srgbClr val="F8FAFC"/>
           </a:solidFill>
-          <a:ln w="25400">
+          <a:ln w="19050">
             <a:solidFill>
-              <a:srgbClr val="10B981"/>
+              <a:srgbClr val="CBD5E1"/>
             </a:solidFill>
             <a:prstDash val="solid"/>
           </a:ln>
@@ -3064,7 +3064,7 @@
             <a:r>
               <a:rPr lang="en-US" sz="1800" b="1" dirty="0">
                 <a:solidFill>
-                  <a:srgbClr val="10B981"/>
+                  <a:srgbClr val="059669"/>
                 </a:solidFill>
                 <a:latin typeface="Segoe UI" pitchFamily="34" charset="0"/>
                 <a:ea typeface="Segoe UI" pitchFamily="34" charset="-122"/>
@@ -3103,13 +3103,13 @@
             <a:r>
               <a:rPr lang="en-US" sz="1300" dirty="0">
                 <a:solidFill>
-                  <a:srgbClr val="CBD5E1"/>
-                </a:solidFill>
-                <a:latin typeface="Segoe UI" pitchFamily="34" charset="0"/>
-                <a:ea typeface="Segoe UI" pitchFamily="34" charset="-122"/>
-                <a:cs typeface="Segoe UI" pitchFamily="34" charset="-120"/>
-              </a:rPr>
-              <a:t>Filter events by Tech, Music, Workshop, Sports, &amp; Art with real-time keyword search.</a:t>
+                  <a:srgbClr val="475569"/>
+                </a:solidFill>
+                <a:latin typeface="Segoe UI" pitchFamily="34" charset="0"/>
+                <a:ea typeface="Segoe UI" pitchFamily="34" charset="-122"/>
+                <a:cs typeface="Segoe UI" pitchFamily="34" charset="-120"/>
+              </a:rPr>
+              <a:t>Filter events by Tech, Music, Workshop, Sports, &amp; Art with keyword search.</a:t>
             </a:r>
             <a:endParaRPr lang="en-US" sz="1300" dirty="0"/>
           </a:p>
@@ -3130,11 +3130,11 @@
             <a:avLst/>
           </a:prstGeom>
           <a:solidFill>
-            <a:srgbClr val="1E293B"/>
+            <a:srgbClr val="F8FAFC"/>
           </a:solidFill>
-          <a:ln w="25400">
+          <a:ln w="19050">
             <a:solidFill>
-              <a:srgbClr val="F59E0B"/>
+              <a:srgbClr val="CBD5E1"/>
             </a:solidFill>
             <a:prstDash val="solid"/>
           </a:ln>
@@ -3167,13 +3167,13 @@
             <a:r>
               <a:rPr lang="en-US" sz="1800" b="1" dirty="0">
                 <a:solidFill>
-                  <a:srgbClr val="F59E0B"/>
-                </a:solidFill>
-                <a:latin typeface="Segoe UI" pitchFamily="34" charset="0"/>
-                <a:ea typeface="Segoe UI" pitchFamily="34" charset="-122"/>
-                <a:cs typeface="Segoe UI" pitchFamily="34" charset="-120"/>
-              </a:rPr>
-              <a:t>Pass Tier Multipliers</a:t>
+                  <a:srgbClr val="D97706"/>
+                </a:solidFill>
+                <a:latin typeface="Segoe UI" pitchFamily="34" charset="0"/>
+                <a:ea typeface="Segoe UI" pitchFamily="34" charset="-122"/>
+                <a:cs typeface="Segoe UI" pitchFamily="34" charset="-120"/>
+              </a:rPr>
+              <a:t>Pass Tier Selection</a:t>
             </a:r>
             <a:endParaRPr lang="en-US" sz="1800" dirty="0"/>
           </a:p>
@@ -3206,13 +3206,13 @@
             <a:r>
               <a:rPr lang="en-US" sz="1300" dirty="0">
                 <a:solidFill>
-                  <a:srgbClr val="CBD5E1"/>
-                </a:solidFill>
-                <a:latin typeface="Segoe UI" pitchFamily="34" charset="0"/>
-                <a:ea typeface="Segoe UI" pitchFamily="34" charset="-122"/>
-                <a:cs typeface="Segoe UI" pitchFamily="34" charset="-120"/>
-              </a:rPr>
-              <a:t>Select Standard or VIP Passes (+50% VIP lounge access calculation).</a:t>
+                  <a:srgbClr val="475569"/>
+                </a:solidFill>
+                <a:latin typeface="Segoe UI" pitchFamily="34" charset="0"/>
+                <a:ea typeface="Segoe UI" pitchFamily="34" charset="-122"/>
+                <a:cs typeface="Segoe UI" pitchFamily="34" charset="-120"/>
+              </a:rPr>
+              <a:t>Select Standard or VIP Passes (+50% VIP lounge access multiplier).</a:t>
             </a:r>
             <a:endParaRPr lang="en-US" sz="1300" dirty="0"/>
           </a:p>
@@ -3233,11 +3233,11 @@
             <a:avLst/>
           </a:prstGeom>
           <a:solidFill>
-            <a:srgbClr val="1E293B"/>
+            <a:srgbClr val="F8FAFC"/>
           </a:solidFill>
-          <a:ln w="25400">
+          <a:ln w="19050">
             <a:solidFill>
-              <a:srgbClr val="60A5FA"/>
+              <a:srgbClr val="CBD5E1"/>
             </a:solidFill>
             <a:prstDash val="solid"/>
           </a:ln>
@@ -3270,13 +3270,13 @@
             <a:r>
               <a:rPr lang="en-US" sz="1800" b="1" dirty="0">
                 <a:solidFill>
-                  <a:srgbClr val="60A5FA"/>
-                </a:solidFill>
-                <a:latin typeface="Segoe UI" pitchFamily="34" charset="0"/>
-                <a:ea typeface="Segoe UI" pitchFamily="34" charset="-122"/>
-                <a:cs typeface="Segoe UI" pitchFamily="34" charset="-120"/>
-              </a:rPr>
-              <a:t>Indian Rupee Pricing</a:t>
+                  <a:srgbClr val="2563EB"/>
+                </a:solidFill>
+                <a:latin typeface="Segoe UI" pitchFamily="34" charset="0"/>
+                <a:ea typeface="Segoe UI" pitchFamily="34" charset="-122"/>
+                <a:cs typeface="Segoe UI" pitchFamily="34" charset="-120"/>
+              </a:rPr>
+              <a:t>Indian Rupee Rates</a:t>
             </a:r>
             <a:endParaRPr lang="en-US" sz="1800" dirty="0"/>
           </a:p>
@@ -3309,13 +3309,13 @@
             <a:r>
               <a:rPr lang="en-US" sz="1300" dirty="0">
                 <a:solidFill>
-                  <a:srgbClr val="CBD5E1"/>
-                </a:solidFill>
-                <a:latin typeface="Segoe UI" pitchFamily="34" charset="0"/>
-                <a:ea typeface="Segoe UI" pitchFamily="34" charset="-122"/>
-                <a:cs typeface="Segoe UI" pitchFamily="34" charset="-120"/>
-              </a:rPr>
-              <a:t>All rates, base prices, and order totals calculated in Indian Rupees (₹).</a:t>
+                  <a:srgbClr val="475569"/>
+                </a:solidFill>
+                <a:latin typeface="Segoe UI" pitchFamily="34" charset="0"/>
+                <a:ea typeface="Segoe UI" pitchFamily="34" charset="-122"/>
+                <a:cs typeface="Segoe UI" pitchFamily="34" charset="-120"/>
+              </a:rPr>
+              <a:t>All prices, base rates, and order totals calculated in Indian Rupees (₹).</a:t>
             </a:r>
             <a:endParaRPr lang="en-US" sz="1300" dirty="0"/>
           </a:p>
@@ -3336,11 +3336,11 @@
             <a:avLst/>
           </a:prstGeom>
           <a:solidFill>
-            <a:srgbClr val="1E293B"/>
+            <a:srgbClr val="F8FAFC"/>
           </a:solidFill>
-          <a:ln w="25400">
+          <a:ln w="19050">
             <a:solidFill>
-              <a:srgbClr val="8B5CF6"/>
+              <a:srgbClr val="CBD5E1"/>
             </a:solidFill>
             <a:prstDash val="solid"/>
           </a:ln>
@@ -3373,7 +3373,7 @@
             <a:r>
               <a:rPr lang="en-US" sz="1800" b="1" dirty="0">
                 <a:solidFill>
-                  <a:srgbClr val="8B5CF6"/>
+                  <a:srgbClr val="7C3AED"/>
                 </a:solidFill>
                 <a:latin typeface="Segoe UI" pitchFamily="34" charset="0"/>
                 <a:ea typeface="Segoe UI" pitchFamily="34" charset="-122"/>
@@ -3412,7 +3412,7 @@
             <a:r>
               <a:rPr lang="en-US" sz="1300" dirty="0">
                 <a:solidFill>
-                  <a:srgbClr val="CBD5E1"/>
+                  <a:srgbClr val="475569"/>
                 </a:solidFill>
                 <a:latin typeface="Segoe UI" pitchFamily="34" charset="0"/>
                 <a:ea typeface="Segoe UI" pitchFamily="34" charset="-122"/>
@@ -3439,11 +3439,11 @@
             <a:avLst/>
           </a:prstGeom>
           <a:solidFill>
-            <a:srgbClr val="1E293B"/>
+            <a:srgbClr val="F8FAFC"/>
           </a:solidFill>
-          <a:ln w="25400">
+          <a:ln w="19050">
             <a:solidFill>
-              <a:srgbClr val="EC4899"/>
+              <a:srgbClr val="CBD5E1"/>
             </a:solidFill>
             <a:prstDash val="solid"/>
           </a:ln>
@@ -3476,7 +3476,7 @@
             <a:r>
               <a:rPr lang="en-US" sz="1800" b="1" dirty="0">
                 <a:solidFill>
-                  <a:srgbClr val="EC4899"/>
+                  <a:srgbClr val="DB2777"/>
                 </a:solidFill>
                 <a:latin typeface="Segoe UI" pitchFamily="34" charset="0"/>
                 <a:ea typeface="Segoe UI" pitchFamily="34" charset="-122"/>
@@ -3515,13 +3515,13 @@
             <a:r>
               <a:rPr lang="en-US" sz="1300" dirty="0">
                 <a:solidFill>
-                  <a:srgbClr val="CBD5E1"/>
-                </a:solidFill>
-                <a:latin typeface="Segoe UI" pitchFamily="34" charset="0"/>
-                <a:ea typeface="Segoe UI" pitchFamily="34" charset="-122"/>
-                <a:cs typeface="Segoe UI" pitchFamily="34" charset="-120"/>
-              </a:rPr>
-              <a:t>Booked tickets automatically link and appear under the user's account portal.</a:t>
+                  <a:srgbClr val="475569"/>
+                </a:solidFill>
+                <a:latin typeface="Segoe UI" pitchFamily="34" charset="0"/>
+                <a:ea typeface="Segoe UI" pitchFamily="34" charset="-122"/>
+                <a:cs typeface="Segoe UI" pitchFamily="34" charset="-120"/>
+              </a:rPr>
+              <a:t>Booked tickets automatically link and display under the user's profile.</a:t>
             </a:r>
             <a:endParaRPr lang="en-US" sz="1300" dirty="0"/>
           </a:p>
@@ -3541,7 +3541,7 @@
     <p:bg>
       <p:bgPr>
         <a:solidFill>
-          <a:srgbClr val="0F172A"/>
+          <a:srgbClr val="FFFFFF"/>
         </a:solidFill>
       </p:bgPr>
     </p:bg>
@@ -3586,13 +3586,13 @@
             <a:r>
               <a:rPr lang="en-US" sz="2600" b="1" dirty="0">
                 <a:solidFill>
-                  <a:srgbClr val="60A5FA"/>
-                </a:solidFill>
-                <a:latin typeface="Segoe UI" pitchFamily="34" charset="0"/>
-                <a:ea typeface="Segoe UI" pitchFamily="34" charset="-122"/>
-                <a:cs typeface="Segoe UI" pitchFamily="34" charset="-120"/>
-              </a:rPr>
-              <a:t>System Architecture &amp; Technology Stack</a:t>
+                  <a:srgbClr val="1E40AF"/>
+                </a:solidFill>
+                <a:latin typeface="Segoe UI" pitchFamily="34" charset="0"/>
+                <a:ea typeface="Segoe UI" pitchFamily="34" charset="-122"/>
+                <a:cs typeface="Segoe UI" pitchFamily="34" charset="-120"/>
+              </a:rPr>
+              <a:t>System Architecture (ASP.NET MVC)</a:t>
             </a:r>
             <a:endParaRPr lang="en-US" sz="2600" dirty="0"/>
           </a:p>
@@ -3615,7 +3615,7 @@
           <a:noFill/>
           <a:ln w="25400">
             <a:solidFill>
-              <a:srgbClr val="334155"/>
+              <a:srgbClr val="E2E8F0"/>
             </a:solidFill>
             <a:prstDash val="solid"/>
           </a:ln>
@@ -3636,11 +3636,11 @@
             <a:avLst/>
           </a:prstGeom>
           <a:solidFill>
-            <a:srgbClr val="1E293B"/>
+            <a:srgbClr val="EFF6FF"/>
           </a:solidFill>
-          <a:ln w="25400">
+          <a:ln w="19050">
             <a:solidFill>
-              <a:srgbClr val="3B82F6"/>
+              <a:srgbClr val="1E40AF"/>
             </a:solidFill>
             <a:prstDash val="solid"/>
           </a:ln>
@@ -3673,7 +3673,7 @@
             <a:r>
               <a:rPr lang="en-US" sz="1400" b="1" dirty="0">
                 <a:solidFill>
-                  <a:srgbClr val="FFFFFF"/>
+                  <a:srgbClr val="0F172A"/>
                 </a:solidFill>
                 <a:latin typeface="Segoe UI" pitchFamily="34" charset="0"/>
                 <a:ea typeface="Segoe UI" pitchFamily="34" charset="-122"/>
@@ -3696,7 +3696,7 @@
             <a:r>
               <a:rPr lang="en-US" sz="1400" b="1" dirty="0">
                 <a:solidFill>
-                  <a:srgbClr val="FFFFFF"/>
+                  <a:srgbClr val="0F172A"/>
                 </a:solidFill>
                 <a:latin typeface="Segoe UI" pitchFamily="34" charset="0"/>
                 <a:ea typeface="Segoe UI" pitchFamily="34" charset="-122"/>
@@ -3713,7 +3713,7 @@
             <a:r>
               <a:rPr lang="en-US" sz="1400" b="1" dirty="0">
                 <a:solidFill>
-                  <a:srgbClr val="FFFFFF"/>
+                  <a:srgbClr val="0F172A"/>
                 </a:solidFill>
                 <a:latin typeface="Segoe UI" pitchFamily="34" charset="0"/>
                 <a:ea typeface="Segoe UI" pitchFamily="34" charset="-122"/>
@@ -3730,7 +3730,7 @@
             <a:r>
               <a:rPr lang="en-US" sz="1400" b="1" dirty="0">
                 <a:solidFill>
-                  <a:srgbClr val="FFFFFF"/>
+                  <a:srgbClr val="0F172A"/>
                 </a:solidFill>
                 <a:latin typeface="Segoe UI" pitchFamily="34" charset="0"/>
                 <a:ea typeface="Segoe UI" pitchFamily="34" charset="-122"/>
@@ -3769,7 +3769,7 @@
             <a:r>
               <a:rPr lang="en-US" sz="2800" dirty="0">
                 <a:solidFill>
-                  <a:srgbClr val="60A5FA"/>
+                  <a:srgbClr val="1E40AF"/>
                 </a:solidFill>
               </a:rPr>
               <a:t>➔</a:t>
@@ -3793,11 +3793,11 @@
             <a:avLst/>
           </a:prstGeom>
           <a:solidFill>
-            <a:srgbClr val="1E293B"/>
+            <a:srgbClr val="ECFDF5"/>
           </a:solidFill>
-          <a:ln w="25400">
+          <a:ln w="19050">
             <a:solidFill>
-              <a:srgbClr val="10B981"/>
+              <a:srgbClr val="059669"/>
             </a:solidFill>
             <a:prstDash val="solid"/>
           </a:ln>
@@ -3830,7 +3830,7 @@
             <a:r>
               <a:rPr lang="en-US" sz="1400" b="1" dirty="0">
                 <a:solidFill>
-                  <a:srgbClr val="FFFFFF"/>
+                  <a:srgbClr val="0F172A"/>
                 </a:solidFill>
                 <a:latin typeface="Segoe UI" pitchFamily="34" charset="0"/>
                 <a:ea typeface="Segoe UI" pitchFamily="34" charset="-122"/>
@@ -3853,7 +3853,7 @@
             <a:r>
               <a:rPr lang="en-US" sz="1400" b="1" dirty="0">
                 <a:solidFill>
-                  <a:srgbClr val="FFFFFF"/>
+                  <a:srgbClr val="0F172A"/>
                 </a:solidFill>
                 <a:latin typeface="Segoe UI" pitchFamily="34" charset="0"/>
                 <a:ea typeface="Segoe UI" pitchFamily="34" charset="-122"/>
@@ -3870,7 +3870,7 @@
             <a:r>
               <a:rPr lang="en-US" sz="1400" b="1" dirty="0">
                 <a:solidFill>
-                  <a:srgbClr val="FFFFFF"/>
+                  <a:srgbClr val="0F172A"/>
                 </a:solidFill>
                 <a:latin typeface="Segoe UI" pitchFamily="34" charset="0"/>
                 <a:ea typeface="Segoe UI" pitchFamily="34" charset="-122"/>
@@ -3887,7 +3887,7 @@
             <a:r>
               <a:rPr lang="en-US" sz="1400" b="1" dirty="0">
                 <a:solidFill>
-                  <a:srgbClr val="FFFFFF"/>
+                  <a:srgbClr val="0F172A"/>
                 </a:solidFill>
                 <a:latin typeface="Segoe UI" pitchFamily="34" charset="0"/>
                 <a:ea typeface="Segoe UI" pitchFamily="34" charset="-122"/>
@@ -3926,7 +3926,7 @@
             <a:r>
               <a:rPr lang="en-US" sz="2800" dirty="0">
                 <a:solidFill>
-                  <a:srgbClr val="60A5FA"/>
+                  <a:srgbClr val="1E40AF"/>
                 </a:solidFill>
               </a:rPr>
               <a:t>➔</a:t>
@@ -3950,11 +3950,11 @@
             <a:avLst/>
           </a:prstGeom>
           <a:solidFill>
-            <a:srgbClr val="1E293B"/>
+            <a:srgbClr val="FEF3C7"/>
           </a:solidFill>
-          <a:ln w="25400">
+          <a:ln w="19050">
             <a:solidFill>
-              <a:srgbClr val="F59E0B"/>
+              <a:srgbClr val="D97706"/>
             </a:solidFill>
             <a:prstDash val="solid"/>
           </a:ln>
@@ -3987,7 +3987,7 @@
             <a:r>
               <a:rPr lang="en-US" sz="1400" b="1" dirty="0">
                 <a:solidFill>
-                  <a:srgbClr val="FFFFFF"/>
+                  <a:srgbClr val="0F172A"/>
                 </a:solidFill>
                 <a:latin typeface="Segoe UI" pitchFamily="34" charset="0"/>
                 <a:ea typeface="Segoe UI" pitchFamily="34" charset="-122"/>
@@ -4010,7 +4010,7 @@
             <a:r>
               <a:rPr lang="en-US" sz="1400" b="1" dirty="0">
                 <a:solidFill>
-                  <a:srgbClr val="FFFFFF"/>
+                  <a:srgbClr val="0F172A"/>
                 </a:solidFill>
                 <a:latin typeface="Segoe UI" pitchFamily="34" charset="0"/>
                 <a:ea typeface="Segoe UI" pitchFamily="34" charset="-122"/>
@@ -4027,7 +4027,7 @@
             <a:r>
               <a:rPr lang="en-US" sz="1400" b="1" dirty="0">
                 <a:solidFill>
-                  <a:srgbClr val="FFFFFF"/>
+                  <a:srgbClr val="0F172A"/>
                 </a:solidFill>
                 <a:latin typeface="Segoe UI" pitchFamily="34" charset="0"/>
                 <a:ea typeface="Segoe UI" pitchFamily="34" charset="-122"/>
@@ -4044,7 +4044,7 @@
             <a:r>
               <a:rPr lang="en-US" sz="1400" b="1" dirty="0">
                 <a:solidFill>
-                  <a:srgbClr val="FFFFFF"/>
+                  <a:srgbClr val="0F172A"/>
                 </a:solidFill>
                 <a:latin typeface="Segoe UI" pitchFamily="34" charset="0"/>
                 <a:ea typeface="Segoe UI" pitchFamily="34" charset="-122"/>
@@ -4071,11 +4071,11 @@
             <a:avLst/>
           </a:prstGeom>
           <a:solidFill>
-            <a:srgbClr val="1E293B"/>
+            <a:srgbClr val="F8FAFC"/>
           </a:solidFill>
-          <a:ln w="12700">
+          <a:ln w="19050">
             <a:solidFill>
-              <a:srgbClr val="60A5FA"/>
+              <a:srgbClr val="CBD5E1"/>
             </a:solidFill>
             <a:prstDash val="solid"/>
           </a:ln>
@@ -4108,7 +4108,7 @@
             <a:r>
               <a:rPr lang="en-US" sz="1800" b="1" dirty="0">
                 <a:solidFill>
-                  <a:srgbClr val="60A5FA"/>
+                  <a:srgbClr val="1E40AF"/>
                 </a:solidFill>
                 <a:latin typeface="Segoe UI" pitchFamily="34" charset="0"/>
                 <a:ea typeface="Segoe UI" pitchFamily="34" charset="-122"/>
@@ -4147,7 +4147,7 @@
             <a:r>
               <a:rPr lang="en-US" sz="1500" dirty="0">
                 <a:solidFill>
-                  <a:srgbClr val="CBD5E1"/>
+                  <a:srgbClr val="475569"/>
                 </a:solidFill>
                 <a:latin typeface="Segoe UI" pitchFamily="34" charset="0"/>
                 <a:ea typeface="Segoe UI" pitchFamily="34" charset="-122"/>
@@ -4164,13 +4164,13 @@
             <a:r>
               <a:rPr lang="en-US" sz="1500" dirty="0">
                 <a:solidFill>
-                  <a:srgbClr val="CBD5E1"/>
-                </a:solidFill>
-                <a:latin typeface="Segoe UI" pitchFamily="34" charset="0"/>
-                <a:ea typeface="Segoe UI" pitchFamily="34" charset="-122"/>
-                <a:cs typeface="Segoe UI" pitchFamily="34" charset="-120"/>
-              </a:rPr>
-              <a:t>• UI Styling: Bootstrap 5, Bootstrap Icons, Custom Site CSS</a:t>
+                  <a:srgbClr val="475569"/>
+                </a:solidFill>
+                <a:latin typeface="Segoe UI" pitchFamily="34" charset="0"/>
+                <a:ea typeface="Segoe UI" pitchFamily="34" charset="-122"/>
+                <a:cs typeface="Segoe UI" pitchFamily="34" charset="-120"/>
+              </a:rPr>
+              <a:t>• UI Framework: Bootstrap 5 &amp; Custom Site CSS</a:t>
             </a:r>
             <a:endParaRPr lang="en-US" sz="1500" dirty="0"/>
           </a:p>
@@ -4181,13 +4181,13 @@
             <a:r>
               <a:rPr lang="en-US" sz="1500" dirty="0">
                 <a:solidFill>
-                  <a:srgbClr val="CBD5E1"/>
-                </a:solidFill>
-                <a:latin typeface="Segoe UI" pitchFamily="34" charset="0"/>
-                <a:ea typeface="Segoe UI" pitchFamily="34" charset="-122"/>
-                <a:cs typeface="Segoe UI" pitchFamily="34" charset="-120"/>
-              </a:rPr>
-              <a:t>• Authentication: ASP.NET Core Session Management</a:t>
+                  <a:srgbClr val="475569"/>
+                </a:solidFill>
+                <a:latin typeface="Segoe UI" pitchFamily="34" charset="0"/>
+                <a:ea typeface="Segoe UI" pitchFamily="34" charset="-122"/>
+                <a:cs typeface="Segoe UI" pitchFamily="34" charset="-120"/>
+              </a:rPr>
+              <a:t>• State Management: ASP.NET Session State</a:t>
             </a:r>
             <a:endParaRPr lang="en-US" sz="1500" dirty="0"/>
           </a:p>
@@ -4198,7 +4198,7 @@
             <a:r>
               <a:rPr lang="en-US" sz="1500" dirty="0">
                 <a:solidFill>
-                  <a:srgbClr val="CBD5E1"/>
+                  <a:srgbClr val="475569"/>
                 </a:solidFill>
                 <a:latin typeface="Segoe UI" pitchFamily="34" charset="0"/>
                 <a:ea typeface="Segoe UI" pitchFamily="34" charset="-122"/>
@@ -4224,7 +4224,7 @@
     <p:bg>
       <p:bgPr>
         <a:solidFill>
-          <a:srgbClr val="0F172A"/>
+          <a:srgbClr val="FFFFFF"/>
         </a:solidFill>
       </p:bgPr>
     </p:bg>
@@ -4269,7 +4269,7 @@
             <a:r>
               <a:rPr lang="en-US" sz="2600" b="1" dirty="0">
                 <a:solidFill>
-                  <a:srgbClr val="60A5FA"/>
+                  <a:srgbClr val="1E40AF"/>
                 </a:solidFill>
                 <a:latin typeface="Segoe UI" pitchFamily="34" charset="0"/>
                 <a:ea typeface="Segoe UI" pitchFamily="34" charset="-122"/>
@@ -4298,7 +4298,7 @@
           <a:noFill/>
           <a:ln w="25400">
             <a:solidFill>
-              <a:srgbClr val="334155"/>
+              <a:srgbClr val="E2E8F0"/>
             </a:solidFill>
             <a:prstDash val="solid"/>
           </a:ln>
@@ -4361,7 +4361,7 @@
                   <a:tcPr marL="91440" marR="91440" marT="45720" marB="45720">
                     <a:lnL w="12700" cap="flat" cmpd="sng" algn="ctr">
                       <a:solidFill>
-                        <a:srgbClr val="334155"/>
+                        <a:srgbClr val="CBD5E1"/>
                       </a:solidFill>
                       <a:prstDash val="solid"/>
                       <a:round/>
@@ -4370,7 +4370,7 @@
                     </a:lnL>
                     <a:lnR w="12700" cap="flat" cmpd="sng" algn="ctr">
                       <a:solidFill>
-                        <a:srgbClr val="334155"/>
+                        <a:srgbClr val="CBD5E1"/>
                       </a:solidFill>
                       <a:prstDash val="solid"/>
                       <a:round/>
@@ -4379,7 +4379,7 @@
                     </a:lnR>
                     <a:lnT w="12700" cap="flat" cmpd="sng" algn="ctr">
                       <a:solidFill>
-                        <a:srgbClr val="334155"/>
+                        <a:srgbClr val="CBD5E1"/>
                       </a:solidFill>
                       <a:prstDash val="solid"/>
                       <a:round/>
@@ -4388,7 +4388,7 @@
                     </a:lnT>
                     <a:lnB w="12700" cap="flat" cmpd="sng" algn="ctr">
                       <a:solidFill>
-                        <a:srgbClr val="334155"/>
+                        <a:srgbClr val="CBD5E1"/>
                       </a:solidFill>
                       <a:prstDash val="solid"/>
                       <a:round/>
@@ -4396,7 +4396,7 @@
                       <a:tailEnd type="none" w="med" len="med"/>
                     </a:lnB>
                     <a:solidFill>
-                      <a:srgbClr val="3B82F6"/>
+                      <a:srgbClr val="1E40AF"/>
                     </a:solidFill>
                   </a:tcPr>
                 </a:tc>
@@ -4429,7 +4429,7 @@
                   <a:tcPr marL="91440" marR="91440" marT="45720" marB="45720">
                     <a:lnL w="12700" cap="flat" cmpd="sng" algn="ctr">
                       <a:solidFill>
-                        <a:srgbClr val="334155"/>
+                        <a:srgbClr val="CBD5E1"/>
                       </a:solidFill>
                       <a:prstDash val="solid"/>
                       <a:round/>
@@ -4438,7 +4438,7 @@
                     </a:lnL>
                     <a:lnR w="12700" cap="flat" cmpd="sng" algn="ctr">
                       <a:solidFill>
-                        <a:srgbClr val="334155"/>
+                        <a:srgbClr val="CBD5E1"/>
                       </a:solidFill>
                       <a:prstDash val="solid"/>
                       <a:round/>
@@ -4447,7 +4447,7 @@
                     </a:lnR>
                     <a:lnT w="12700" cap="flat" cmpd="sng" algn="ctr">
                       <a:solidFill>
-                        <a:srgbClr val="334155"/>
+                        <a:srgbClr val="CBD5E1"/>
                       </a:solidFill>
                       <a:prstDash val="solid"/>
                       <a:round/>
@@ -4456,7 +4456,7 @@
                     </a:lnT>
                     <a:lnB w="12700" cap="flat" cmpd="sng" algn="ctr">
                       <a:solidFill>
-                        <a:srgbClr val="334155"/>
+                        <a:srgbClr val="CBD5E1"/>
                       </a:solidFill>
                       <a:prstDash val="solid"/>
                       <a:round/>
@@ -4464,7 +4464,7 @@
                       <a:tailEnd type="none" w="med" len="med"/>
                     </a:lnB>
                     <a:solidFill>
-                      <a:srgbClr val="3B82F6"/>
+                      <a:srgbClr val="1E40AF"/>
                     </a:solidFill>
                   </a:tcPr>
                 </a:tc>
@@ -4497,7 +4497,7 @@
                   <a:tcPr marL="91440" marR="91440" marT="45720" marB="45720">
                     <a:lnL w="12700" cap="flat" cmpd="sng" algn="ctr">
                       <a:solidFill>
-                        <a:srgbClr val="334155"/>
+                        <a:srgbClr val="CBD5E1"/>
                       </a:solidFill>
                       <a:prstDash val="solid"/>
                       <a:round/>
@@ -4506,7 +4506,7 @@
                     </a:lnL>
                     <a:lnR w="12700" cap="flat" cmpd="sng" algn="ctr">
                       <a:solidFill>
-                        <a:srgbClr val="334155"/>
+                        <a:srgbClr val="CBD5E1"/>
                       </a:solidFill>
                       <a:prstDash val="solid"/>
                       <a:round/>
@@ -4515,7 +4515,7 @@
                     </a:lnR>
                     <a:lnT w="12700" cap="flat" cmpd="sng" algn="ctr">
                       <a:solidFill>
-                        <a:srgbClr val="334155"/>
+                        <a:srgbClr val="CBD5E1"/>
                       </a:solidFill>
                       <a:prstDash val="solid"/>
                       <a:round/>
@@ -4524,7 +4524,7 @@
                     </a:lnT>
                     <a:lnB w="12700" cap="flat" cmpd="sng" algn="ctr">
                       <a:solidFill>
-                        <a:srgbClr val="334155"/>
+                        <a:srgbClr val="CBD5E1"/>
                       </a:solidFill>
                       <a:prstDash val="solid"/>
                       <a:round/>
@@ -4532,7 +4532,7 @@
                       <a:tailEnd type="none" w="med" len="med"/>
                     </a:lnB>
                     <a:solidFill>
-                      <a:srgbClr val="3B82F6"/>
+                      <a:srgbClr val="1E40AF"/>
                     </a:solidFill>
                   </a:tcPr>
                 </a:tc>
@@ -4549,7 +4549,7 @@
                       <a:r>
                         <a:rPr lang="en-US" sz="1300" dirty="0">
                           <a:solidFill>
-                            <a:srgbClr val="CBD5E1"/>
+                            <a:srgbClr val="0F172A"/>
                           </a:solidFill>
                           <a:latin typeface="Segoe UI" pitchFamily="34" charset="0"/>
                           <a:ea typeface="Segoe UI" pitchFamily="34" charset="-122"/>
@@ -4567,7 +4567,7 @@
                   <a:tcPr marL="91440" marR="91440" marT="45720" marB="45720">
                     <a:lnL w="12700" cap="flat" cmpd="sng" algn="ctr">
                       <a:solidFill>
-                        <a:srgbClr val="334155"/>
+                        <a:srgbClr val="CBD5E1"/>
                       </a:solidFill>
                       <a:prstDash val="solid"/>
                       <a:round/>
@@ -4576,7 +4576,7 @@
                     </a:lnL>
                     <a:lnR w="12700" cap="flat" cmpd="sng" algn="ctr">
                       <a:solidFill>
-                        <a:srgbClr val="334155"/>
+                        <a:srgbClr val="CBD5E1"/>
                       </a:solidFill>
                       <a:prstDash val="solid"/>
                       <a:round/>
@@ -4585,7 +4585,7 @@
                     </a:lnR>
                     <a:lnT w="12700" cap="flat" cmpd="sng" algn="ctr">
                       <a:solidFill>
-                        <a:srgbClr val="334155"/>
+                        <a:srgbClr val="CBD5E1"/>
                       </a:solidFill>
                       <a:prstDash val="solid"/>
                       <a:round/>
@@ -4594,7 +4594,7 @@
                     </a:lnT>
                     <a:lnB w="12700" cap="flat" cmpd="sng" algn="ctr">
                       <a:solidFill>
-                        <a:srgbClr val="334155"/>
+                        <a:srgbClr val="CBD5E1"/>
                       </a:solidFill>
                       <a:prstDash val="solid"/>
                       <a:round/>
@@ -4614,7 +4614,7 @@
                       <a:r>
                         <a:rPr lang="en-US" sz="1300" dirty="0">
                           <a:solidFill>
-                            <a:srgbClr val="CBD5E1"/>
+                            <a:srgbClr val="0F172A"/>
                           </a:solidFill>
                           <a:latin typeface="Segoe UI" pitchFamily="34" charset="0"/>
                           <a:ea typeface="Segoe UI" pitchFamily="34" charset="-122"/>
@@ -4632,7 +4632,7 @@
                   <a:tcPr marL="91440" marR="91440" marT="45720" marB="45720">
                     <a:lnL w="12700" cap="flat" cmpd="sng" algn="ctr">
                       <a:solidFill>
-                        <a:srgbClr val="334155"/>
+                        <a:srgbClr val="CBD5E1"/>
                       </a:solidFill>
                       <a:prstDash val="solid"/>
                       <a:round/>
@@ -4641,7 +4641,7 @@
                     </a:lnL>
                     <a:lnR w="12700" cap="flat" cmpd="sng" algn="ctr">
                       <a:solidFill>
-                        <a:srgbClr val="334155"/>
+                        <a:srgbClr val="CBD5E1"/>
                       </a:solidFill>
                       <a:prstDash val="solid"/>
                       <a:round/>
@@ -4650,7 +4650,7 @@
                     </a:lnR>
                     <a:lnT w="12700" cap="flat" cmpd="sng" algn="ctr">
                       <a:solidFill>
-                        <a:srgbClr val="334155"/>
+                        <a:srgbClr val="CBD5E1"/>
                       </a:solidFill>
                       <a:prstDash val="solid"/>
                       <a:round/>
@@ -4659,7 +4659,7 @@
                     </a:lnT>
                     <a:lnB w="12700" cap="flat" cmpd="sng" algn="ctr">
                       <a:solidFill>
-                        <a:srgbClr val="334155"/>
+                        <a:srgbClr val="CBD5E1"/>
                       </a:solidFill>
                       <a:prstDash val="solid"/>
                       <a:round/>
@@ -4679,7 +4679,7 @@
                       <a:r>
                         <a:rPr lang="en-US" sz="1300" dirty="0">
                           <a:solidFill>
-                            <a:srgbClr val="CBD5E1"/>
+                            <a:srgbClr val="0F172A"/>
                           </a:solidFill>
                           <a:latin typeface="Segoe UI" pitchFamily="34" charset="0"/>
                           <a:ea typeface="Segoe UI" pitchFamily="34" charset="-122"/>
@@ -4697,7 +4697,7 @@
                   <a:tcPr marL="91440" marR="91440" marT="45720" marB="45720">
                     <a:lnL w="12700" cap="flat" cmpd="sng" algn="ctr">
                       <a:solidFill>
-                        <a:srgbClr val="334155"/>
+                        <a:srgbClr val="CBD5E1"/>
                       </a:solidFill>
                       <a:prstDash val="solid"/>
                       <a:round/>
@@ -4706,7 +4706,7 @@
                     </a:lnL>
                     <a:lnR w="12700" cap="flat" cmpd="sng" algn="ctr">
                       <a:solidFill>
-                        <a:srgbClr val="334155"/>
+                        <a:srgbClr val="CBD5E1"/>
                       </a:solidFill>
                       <a:prstDash val="solid"/>
                       <a:round/>
@@ -4715,7 +4715,7 @@
                     </a:lnR>
                     <a:lnT w="12700" cap="flat" cmpd="sng" algn="ctr">
                       <a:solidFill>
-                        <a:srgbClr val="334155"/>
+                        <a:srgbClr val="CBD5E1"/>
                       </a:solidFill>
                       <a:prstDash val="solid"/>
                       <a:round/>
@@ -4724,7 +4724,7 @@
                     </a:lnT>
                     <a:lnB w="12700" cap="flat" cmpd="sng" algn="ctr">
                       <a:solidFill>
-                        <a:srgbClr val="334155"/>
+                        <a:srgbClr val="CBD5E1"/>
                       </a:solidFill>
                       <a:prstDash val="solid"/>
                       <a:round/>
@@ -4746,7 +4746,7 @@
                       <a:r>
                         <a:rPr lang="en-US" sz="1300" dirty="0">
                           <a:solidFill>
-                            <a:srgbClr val="CBD5E1"/>
+                            <a:srgbClr val="0F172A"/>
                           </a:solidFill>
                           <a:latin typeface="Segoe UI" pitchFamily="34" charset="0"/>
                           <a:ea typeface="Segoe UI" pitchFamily="34" charset="-122"/>
@@ -4764,7 +4764,7 @@
                   <a:tcPr marL="91440" marR="91440" marT="45720" marB="45720">
                     <a:lnL w="12700" cap="flat" cmpd="sng" algn="ctr">
                       <a:solidFill>
-                        <a:srgbClr val="334155"/>
+                        <a:srgbClr val="CBD5E1"/>
                       </a:solidFill>
                       <a:prstDash val="solid"/>
                       <a:round/>
@@ -4773,7 +4773,7 @@
                     </a:lnL>
                     <a:lnR w="12700" cap="flat" cmpd="sng" algn="ctr">
                       <a:solidFill>
-                        <a:srgbClr val="334155"/>
+                        <a:srgbClr val="CBD5E1"/>
                       </a:solidFill>
                       <a:prstDash val="solid"/>
                       <a:round/>
@@ -4782,7 +4782,7 @@
                     </a:lnR>
                     <a:lnT w="12700" cap="flat" cmpd="sng" algn="ctr">
                       <a:solidFill>
-                        <a:srgbClr val="334155"/>
+                        <a:srgbClr val="CBD5E1"/>
                       </a:solidFill>
                       <a:prstDash val="solid"/>
                       <a:round/>
@@ -4791,7 +4791,7 @@
                     </a:lnT>
                     <a:lnB w="12700" cap="flat" cmpd="sng" algn="ctr">
                       <a:solidFill>
-                        <a:srgbClr val="334155"/>
+                        <a:srgbClr val="CBD5E1"/>
                       </a:solidFill>
                       <a:prstDash val="solid"/>
                       <a:round/>
@@ -4811,7 +4811,7 @@
                       <a:r>
                         <a:rPr lang="en-US" sz="1300" dirty="0">
                           <a:solidFill>
-                            <a:srgbClr val="CBD5E1"/>
+                            <a:srgbClr val="0F172A"/>
                           </a:solidFill>
                           <a:latin typeface="Segoe UI" pitchFamily="34" charset="0"/>
                           <a:ea typeface="Segoe UI" pitchFamily="34" charset="-122"/>
@@ -4829,7 +4829,7 @@
                   <a:tcPr marL="91440" marR="91440" marT="45720" marB="45720">
                     <a:lnL w="12700" cap="flat" cmpd="sng" algn="ctr">
                       <a:solidFill>
-                        <a:srgbClr val="334155"/>
+                        <a:srgbClr val="CBD5E1"/>
                       </a:solidFill>
                       <a:prstDash val="solid"/>
                       <a:round/>
@@ -4838,7 +4838,7 @@
                     </a:lnL>
                     <a:lnR w="12700" cap="flat" cmpd="sng" algn="ctr">
                       <a:solidFill>
-                        <a:srgbClr val="334155"/>
+                        <a:srgbClr val="CBD5E1"/>
                       </a:solidFill>
                       <a:prstDash val="solid"/>
                       <a:round/>
@@ -4847,7 +4847,7 @@
                     </a:lnR>
                     <a:lnT w="12700" cap="flat" cmpd="sng" algn="ctr">
                       <a:solidFill>
-                        <a:srgbClr val="334155"/>
+                        <a:srgbClr val="CBD5E1"/>
                       </a:solidFill>
                       <a:prstDash val="solid"/>
                       <a:round/>
@@ -4856,7 +4856,7 @@
                     </a:lnT>
                     <a:lnB w="12700" cap="flat" cmpd="sng" algn="ctr">
                       <a:solidFill>
-                        <a:srgbClr val="334155"/>
+                        <a:srgbClr val="CBD5E1"/>
                       </a:solidFill>
                       <a:prstDash val="solid"/>
                       <a:round/>
@@ -4876,7 +4876,7 @@
                       <a:r>
                         <a:rPr lang="en-US" sz="1300" dirty="0">
                           <a:solidFill>
-                            <a:srgbClr val="CBD5E1"/>
+                            <a:srgbClr val="0F172A"/>
                           </a:solidFill>
                           <a:latin typeface="Segoe UI" pitchFamily="34" charset="0"/>
                           <a:ea typeface="Segoe UI" pitchFamily="34" charset="-122"/>
@@ -4894,7 +4894,7 @@
                   <a:tcPr marL="91440" marR="91440" marT="45720" marB="45720">
                     <a:lnL w="12700" cap="flat" cmpd="sng" algn="ctr">
                       <a:solidFill>
-                        <a:srgbClr val="334155"/>
+                        <a:srgbClr val="CBD5E1"/>
                       </a:solidFill>
                       <a:prstDash val="solid"/>
                       <a:round/>
@@ -4903,7 +4903,7 @@
                     </a:lnL>
                     <a:lnR w="12700" cap="flat" cmpd="sng" algn="ctr">
                       <a:solidFill>
-                        <a:srgbClr val="334155"/>
+                        <a:srgbClr val="CBD5E1"/>
                       </a:solidFill>
                       <a:prstDash val="solid"/>
                       <a:round/>
@@ -4912,7 +4912,7 @@
                     </a:lnR>
                     <a:lnT w="12700" cap="flat" cmpd="sng" algn="ctr">
                       <a:solidFill>
-                        <a:srgbClr val="334155"/>
+                        <a:srgbClr val="CBD5E1"/>
                       </a:solidFill>
                       <a:prstDash val="solid"/>
                       <a:round/>
@@ -4921,7 +4921,7 @@
                     </a:lnT>
                     <a:lnB w="12700" cap="flat" cmpd="sng" algn="ctr">
                       <a:solidFill>
-                        <a:srgbClr val="334155"/>
+                        <a:srgbClr val="CBD5E1"/>
                       </a:solidFill>
                       <a:prstDash val="solid"/>
                       <a:round/>
@@ -4943,7 +4943,7 @@
                       <a:r>
                         <a:rPr lang="en-US" sz="1300" dirty="0">
                           <a:solidFill>
-                            <a:srgbClr val="CBD5E1"/>
+                            <a:srgbClr val="0F172A"/>
                           </a:solidFill>
                           <a:latin typeface="Segoe UI" pitchFamily="34" charset="0"/>
                           <a:ea typeface="Segoe UI" pitchFamily="34" charset="-122"/>
@@ -4961,7 +4961,7 @@
                   <a:tcPr marL="91440" marR="91440" marT="45720" marB="45720">
                     <a:lnL w="12700" cap="flat" cmpd="sng" algn="ctr">
                       <a:solidFill>
-                        <a:srgbClr val="334155"/>
+                        <a:srgbClr val="CBD5E1"/>
                       </a:solidFill>
                       <a:prstDash val="solid"/>
                       <a:round/>
@@ -4970,7 +4970,7 @@
                     </a:lnL>
                     <a:lnR w="12700" cap="flat" cmpd="sng" algn="ctr">
                       <a:solidFill>
-                        <a:srgbClr val="334155"/>
+                        <a:srgbClr val="CBD5E1"/>
                       </a:solidFill>
                       <a:prstDash val="solid"/>
                       <a:round/>
@@ -4979,7 +4979,7 @@
                     </a:lnR>
                     <a:lnT w="12700" cap="flat" cmpd="sng" algn="ctr">
                       <a:solidFill>
-                        <a:srgbClr val="334155"/>
+                        <a:srgbClr val="CBD5E1"/>
                       </a:solidFill>
                       <a:prstDash val="solid"/>
                       <a:round/>
@@ -4988,7 +4988,7 @@
                     </a:lnT>
                     <a:lnB w="12700" cap="flat" cmpd="sng" algn="ctr">
                       <a:solidFill>
-                        <a:srgbClr val="334155"/>
+                        <a:srgbClr val="CBD5E1"/>
                       </a:solidFill>
                       <a:prstDash val="solid"/>
                       <a:round/>
@@ -5008,7 +5008,7 @@
                       <a:r>
                         <a:rPr lang="en-US" sz="1300" dirty="0">
                           <a:solidFill>
-                            <a:srgbClr val="CBD5E1"/>
+                            <a:srgbClr val="0F172A"/>
                           </a:solidFill>
                           <a:latin typeface="Segoe UI" pitchFamily="34" charset="0"/>
                           <a:ea typeface="Segoe UI" pitchFamily="34" charset="-122"/>
@@ -5026,7 +5026,7 @@
                   <a:tcPr marL="91440" marR="91440" marT="45720" marB="45720">
                     <a:lnL w="12700" cap="flat" cmpd="sng" algn="ctr">
                       <a:solidFill>
-                        <a:srgbClr val="334155"/>
+                        <a:srgbClr val="CBD5E1"/>
                       </a:solidFill>
                       <a:prstDash val="solid"/>
                       <a:round/>
@@ -5035,7 +5035,7 @@
                     </a:lnL>
                     <a:lnR w="12700" cap="flat" cmpd="sng" algn="ctr">
                       <a:solidFill>
-                        <a:srgbClr val="334155"/>
+                        <a:srgbClr val="CBD5E1"/>
                       </a:solidFill>
                       <a:prstDash val="solid"/>
                       <a:round/>
@@ -5044,7 +5044,7 @@
                     </a:lnR>
                     <a:lnT w="12700" cap="flat" cmpd="sng" algn="ctr">
                       <a:solidFill>
-                        <a:srgbClr val="334155"/>
+                        <a:srgbClr val="CBD5E1"/>
                       </a:solidFill>
                       <a:prstDash val="solid"/>
                       <a:round/>
@@ -5053,7 +5053,7 @@
                     </a:lnT>
                     <a:lnB w="12700" cap="flat" cmpd="sng" algn="ctr">
                       <a:solidFill>
-                        <a:srgbClr val="334155"/>
+                        <a:srgbClr val="CBD5E1"/>
                       </a:solidFill>
                       <a:prstDash val="solid"/>
                       <a:round/>
@@ -5073,7 +5073,7 @@
                       <a:r>
                         <a:rPr lang="en-US" sz="1300" dirty="0">
                           <a:solidFill>
-                            <a:srgbClr val="CBD5E1"/>
+                            <a:srgbClr val="0F172A"/>
                           </a:solidFill>
                           <a:latin typeface="Segoe UI" pitchFamily="34" charset="0"/>
                           <a:ea typeface="Segoe UI" pitchFamily="34" charset="-122"/>
@@ -5091,7 +5091,7 @@
                   <a:tcPr marL="91440" marR="91440" marT="45720" marB="45720">
                     <a:lnL w="12700" cap="flat" cmpd="sng" algn="ctr">
                       <a:solidFill>
-                        <a:srgbClr val="334155"/>
+                        <a:srgbClr val="CBD5E1"/>
                       </a:solidFill>
                       <a:prstDash val="solid"/>
                       <a:round/>
@@ -5100,7 +5100,7 @@
                     </a:lnL>
                     <a:lnR w="12700" cap="flat" cmpd="sng" algn="ctr">
                       <a:solidFill>
-                        <a:srgbClr val="334155"/>
+                        <a:srgbClr val="CBD5E1"/>
                       </a:solidFill>
                       <a:prstDash val="solid"/>
                       <a:round/>
@@ -5109,7 +5109,7 @@
                     </a:lnR>
                     <a:lnT w="12700" cap="flat" cmpd="sng" algn="ctr">
                       <a:solidFill>
-                        <a:srgbClr val="334155"/>
+                        <a:srgbClr val="CBD5E1"/>
                       </a:solidFill>
                       <a:prstDash val="solid"/>
                       <a:round/>
@@ -5118,7 +5118,7 @@
                     </a:lnT>
                     <a:lnB w="12700" cap="flat" cmpd="sng" algn="ctr">
                       <a:solidFill>
-                        <a:srgbClr val="334155"/>
+                        <a:srgbClr val="CBD5E1"/>
                       </a:solidFill>
                       <a:prstDash val="solid"/>
                       <a:round/>
@@ -5140,7 +5140,7 @@
                       <a:r>
                         <a:rPr lang="en-US" sz="1300" dirty="0">
                           <a:solidFill>
-                            <a:srgbClr val="CBD5E1"/>
+                            <a:srgbClr val="0F172A"/>
                           </a:solidFill>
                           <a:latin typeface="Segoe UI" pitchFamily="34" charset="0"/>
                           <a:ea typeface="Segoe UI" pitchFamily="34" charset="-122"/>
@@ -5158,7 +5158,7 @@
                   <a:tcPr marL="91440" marR="91440" marT="45720" marB="45720">
                     <a:lnL w="12700" cap="flat" cmpd="sng" algn="ctr">
                       <a:solidFill>
-                        <a:srgbClr val="334155"/>
+                        <a:srgbClr val="CBD5E1"/>
                       </a:solidFill>
                       <a:prstDash val="solid"/>
                       <a:round/>
@@ -5167,7 +5167,7 @@
                     </a:lnL>
                     <a:lnR w="12700" cap="flat" cmpd="sng" algn="ctr">
                       <a:solidFill>
-                        <a:srgbClr val="334155"/>
+                        <a:srgbClr val="CBD5E1"/>
                       </a:solidFill>
                       <a:prstDash val="solid"/>
                       <a:round/>
@@ -5176,7 +5176,7 @@
                     </a:lnR>
                     <a:lnT w="12700" cap="flat" cmpd="sng" algn="ctr">
                       <a:solidFill>
-                        <a:srgbClr val="334155"/>
+                        <a:srgbClr val="CBD5E1"/>
                       </a:solidFill>
                       <a:prstDash val="solid"/>
                       <a:round/>
@@ -5185,7 +5185,7 @@
                     </a:lnT>
                     <a:lnB w="12700" cap="flat" cmpd="sng" algn="ctr">
                       <a:solidFill>
-                        <a:srgbClr val="334155"/>
+                        <a:srgbClr val="CBD5E1"/>
                       </a:solidFill>
                       <a:prstDash val="solid"/>
                       <a:round/>
@@ -5205,7 +5205,7 @@
                       <a:r>
                         <a:rPr lang="en-US" sz="1300" dirty="0">
                           <a:solidFill>
-                            <a:srgbClr val="CBD5E1"/>
+                            <a:srgbClr val="0F172A"/>
                           </a:solidFill>
                           <a:latin typeface="Segoe UI" pitchFamily="34" charset="0"/>
                           <a:ea typeface="Segoe UI" pitchFamily="34" charset="-122"/>
@@ -5223,7 +5223,7 @@
                   <a:tcPr marL="91440" marR="91440" marT="45720" marB="45720">
                     <a:lnL w="12700" cap="flat" cmpd="sng" algn="ctr">
                       <a:solidFill>
-                        <a:srgbClr val="334155"/>
+                        <a:srgbClr val="CBD5E1"/>
                       </a:solidFill>
                       <a:prstDash val="solid"/>
                       <a:round/>
@@ -5232,7 +5232,7 @@
                     </a:lnL>
                     <a:lnR w="12700" cap="flat" cmpd="sng" algn="ctr">
                       <a:solidFill>
-                        <a:srgbClr val="334155"/>
+                        <a:srgbClr val="CBD5E1"/>
                       </a:solidFill>
                       <a:prstDash val="solid"/>
                       <a:round/>
@@ -5241,7 +5241,7 @@
                     </a:lnR>
                     <a:lnT w="12700" cap="flat" cmpd="sng" algn="ctr">
                       <a:solidFill>
-                        <a:srgbClr val="334155"/>
+                        <a:srgbClr val="CBD5E1"/>
                       </a:solidFill>
                       <a:prstDash val="solid"/>
                       <a:round/>
@@ -5250,7 +5250,7 @@
                     </a:lnT>
                     <a:lnB w="12700" cap="flat" cmpd="sng" algn="ctr">
                       <a:solidFill>
-                        <a:srgbClr val="334155"/>
+                        <a:srgbClr val="CBD5E1"/>
                       </a:solidFill>
                       <a:prstDash val="solid"/>
                       <a:round/>
@@ -5270,7 +5270,7 @@
                       <a:r>
                         <a:rPr lang="en-US" sz="1300" dirty="0">
                           <a:solidFill>
-                            <a:srgbClr val="CBD5E1"/>
+                            <a:srgbClr val="0F172A"/>
                           </a:solidFill>
                           <a:latin typeface="Segoe UI" pitchFamily="34" charset="0"/>
                           <a:ea typeface="Segoe UI" pitchFamily="34" charset="-122"/>
@@ -5288,7 +5288,7 @@
                   <a:tcPr marL="91440" marR="91440" marT="45720" marB="45720">
                     <a:lnL w="12700" cap="flat" cmpd="sng" algn="ctr">
                       <a:solidFill>
-                        <a:srgbClr val="334155"/>
+                        <a:srgbClr val="CBD5E1"/>
                       </a:solidFill>
                       <a:prstDash val="solid"/>
                       <a:round/>
@@ -5297,7 +5297,7 @@
                     </a:lnL>
                     <a:lnR w="12700" cap="flat" cmpd="sng" algn="ctr">
                       <a:solidFill>
-                        <a:srgbClr val="334155"/>
+                        <a:srgbClr val="CBD5E1"/>
                       </a:solidFill>
                       <a:prstDash val="solid"/>
                       <a:round/>
@@ -5306,7 +5306,7 @@
                     </a:lnR>
                     <a:lnT w="12700" cap="flat" cmpd="sng" algn="ctr">
                       <a:solidFill>
-                        <a:srgbClr val="334155"/>
+                        <a:srgbClr val="CBD5E1"/>
                       </a:solidFill>
                       <a:prstDash val="solid"/>
                       <a:round/>
@@ -5315,7 +5315,7 @@
                     </a:lnT>
                     <a:lnB w="12700" cap="flat" cmpd="sng" algn="ctr">
                       <a:solidFill>
-                        <a:srgbClr val="334155"/>
+                        <a:srgbClr val="CBD5E1"/>
                       </a:solidFill>
                       <a:prstDash val="solid"/>
                       <a:round/>
@@ -5337,7 +5337,7 @@
                       <a:r>
                         <a:rPr lang="en-US" sz="1300" dirty="0">
                           <a:solidFill>
-                            <a:srgbClr val="CBD5E1"/>
+                            <a:srgbClr val="0F172A"/>
                           </a:solidFill>
                           <a:latin typeface="Segoe UI" pitchFamily="34" charset="0"/>
                           <a:ea typeface="Segoe UI" pitchFamily="34" charset="-122"/>
@@ -5355,7 +5355,7 @@
                   <a:tcPr marL="91440" marR="91440" marT="45720" marB="45720">
                     <a:lnL w="12700" cap="flat" cmpd="sng" algn="ctr">
                       <a:solidFill>
-                        <a:srgbClr val="334155"/>
+                        <a:srgbClr val="CBD5E1"/>
                       </a:solidFill>
                       <a:prstDash val="solid"/>
                       <a:round/>
@@ -5364,7 +5364,7 @@
                     </a:lnL>
                     <a:lnR w="12700" cap="flat" cmpd="sng" algn="ctr">
                       <a:solidFill>
-                        <a:srgbClr val="334155"/>
+                        <a:srgbClr val="CBD5E1"/>
                       </a:solidFill>
                       <a:prstDash val="solid"/>
                       <a:round/>
@@ -5373,7 +5373,7 @@
                     </a:lnR>
                     <a:lnT w="12700" cap="flat" cmpd="sng" algn="ctr">
                       <a:solidFill>
-                        <a:srgbClr val="334155"/>
+                        <a:srgbClr val="CBD5E1"/>
                       </a:solidFill>
                       <a:prstDash val="solid"/>
                       <a:round/>
@@ -5382,7 +5382,7 @@
                     </a:lnT>
                     <a:lnB w="12700" cap="flat" cmpd="sng" algn="ctr">
                       <a:solidFill>
-                        <a:srgbClr val="334155"/>
+                        <a:srgbClr val="CBD5E1"/>
                       </a:solidFill>
                       <a:prstDash val="solid"/>
                       <a:round/>
@@ -5402,7 +5402,7 @@
                       <a:r>
                         <a:rPr lang="en-US" sz="1300" dirty="0">
                           <a:solidFill>
-                            <a:srgbClr val="CBD5E1"/>
+                            <a:srgbClr val="0F172A"/>
                           </a:solidFill>
                           <a:latin typeface="Segoe UI" pitchFamily="34" charset="0"/>
                           <a:ea typeface="Segoe UI" pitchFamily="34" charset="-122"/>
@@ -5420,7 +5420,7 @@
                   <a:tcPr marL="91440" marR="91440" marT="45720" marB="45720">
                     <a:lnL w="12700" cap="flat" cmpd="sng" algn="ctr">
                       <a:solidFill>
-                        <a:srgbClr val="334155"/>
+                        <a:srgbClr val="CBD5E1"/>
                       </a:solidFill>
                       <a:prstDash val="solid"/>
                       <a:round/>
@@ -5429,7 +5429,7 @@
                     </a:lnL>
                     <a:lnR w="12700" cap="flat" cmpd="sng" algn="ctr">
                       <a:solidFill>
-                        <a:srgbClr val="334155"/>
+                        <a:srgbClr val="CBD5E1"/>
                       </a:solidFill>
                       <a:prstDash val="solid"/>
                       <a:round/>
@@ -5438,7 +5438,7 @@
                     </a:lnR>
                     <a:lnT w="12700" cap="flat" cmpd="sng" algn="ctr">
                       <a:solidFill>
-                        <a:srgbClr val="334155"/>
+                        <a:srgbClr val="CBD5E1"/>
                       </a:solidFill>
                       <a:prstDash val="solid"/>
                       <a:round/>
@@ -5447,7 +5447,7 @@
                     </a:lnT>
                     <a:lnB w="12700" cap="flat" cmpd="sng" algn="ctr">
                       <a:solidFill>
-                        <a:srgbClr val="334155"/>
+                        <a:srgbClr val="CBD5E1"/>
                       </a:solidFill>
                       <a:prstDash val="solid"/>
                       <a:round/>
@@ -5467,7 +5467,7 @@
                       <a:r>
                         <a:rPr lang="en-US" sz="1300" dirty="0">
                           <a:solidFill>
-                            <a:srgbClr val="CBD5E1"/>
+                            <a:srgbClr val="0F172A"/>
                           </a:solidFill>
                           <a:latin typeface="Segoe UI" pitchFamily="34" charset="0"/>
                           <a:ea typeface="Segoe UI" pitchFamily="34" charset="-122"/>
@@ -5485,7 +5485,7 @@
                   <a:tcPr marL="91440" marR="91440" marT="45720" marB="45720">
                     <a:lnL w="12700" cap="flat" cmpd="sng" algn="ctr">
                       <a:solidFill>
-                        <a:srgbClr val="334155"/>
+                        <a:srgbClr val="CBD5E1"/>
                       </a:solidFill>
                       <a:prstDash val="solid"/>
                       <a:round/>
@@ -5494,7 +5494,7 @@
                     </a:lnL>
                     <a:lnR w="12700" cap="flat" cmpd="sng" algn="ctr">
                       <a:solidFill>
-                        <a:srgbClr val="334155"/>
+                        <a:srgbClr val="CBD5E1"/>
                       </a:solidFill>
                       <a:prstDash val="solid"/>
                       <a:round/>
@@ -5503,7 +5503,7 @@
                     </a:lnR>
                     <a:lnT w="12700" cap="flat" cmpd="sng" algn="ctr">
                       <a:solidFill>
-                        <a:srgbClr val="334155"/>
+                        <a:srgbClr val="CBD5E1"/>
                       </a:solidFill>
                       <a:prstDash val="solid"/>
                       <a:round/>
@@ -5512,7 +5512,7 @@
                     </a:lnT>
                     <a:lnB w="12700" cap="flat" cmpd="sng" algn="ctr">
                       <a:solidFill>
-                        <a:srgbClr val="334155"/>
+                        <a:srgbClr val="CBD5E1"/>
                       </a:solidFill>
                       <a:prstDash val="solid"/>
                       <a:round/>
@@ -5534,7 +5534,7 @@
                       <a:r>
                         <a:rPr lang="en-US" sz="1300" dirty="0">
                           <a:solidFill>
-                            <a:srgbClr val="CBD5E1"/>
+                            <a:srgbClr val="0F172A"/>
                           </a:solidFill>
                           <a:latin typeface="Segoe UI" pitchFamily="34" charset="0"/>
                           <a:ea typeface="Segoe UI" pitchFamily="34" charset="-122"/>
@@ -5552,7 +5552,7 @@
                   <a:tcPr marL="91440" marR="91440" marT="45720" marB="45720">
                     <a:lnL w="12700" cap="flat" cmpd="sng" algn="ctr">
                       <a:solidFill>
-                        <a:srgbClr val="334155"/>
+                        <a:srgbClr val="CBD5E1"/>
                       </a:solidFill>
                       <a:prstDash val="solid"/>
                       <a:round/>
@@ -5561,7 +5561,7 @@
                     </a:lnL>
                     <a:lnR w="12700" cap="flat" cmpd="sng" algn="ctr">
                       <a:solidFill>
-                        <a:srgbClr val="334155"/>
+                        <a:srgbClr val="CBD5E1"/>
                       </a:solidFill>
                       <a:prstDash val="solid"/>
                       <a:round/>
@@ -5570,7 +5570,7 @@
                     </a:lnR>
                     <a:lnT w="12700" cap="flat" cmpd="sng" algn="ctr">
                       <a:solidFill>
-                        <a:srgbClr val="334155"/>
+                        <a:srgbClr val="CBD5E1"/>
                       </a:solidFill>
                       <a:prstDash val="solid"/>
                       <a:round/>
@@ -5579,7 +5579,7 @@
                     </a:lnT>
                     <a:lnB w="12700" cap="flat" cmpd="sng" algn="ctr">
                       <a:solidFill>
-                        <a:srgbClr val="334155"/>
+                        <a:srgbClr val="CBD5E1"/>
                       </a:solidFill>
                       <a:prstDash val="solid"/>
                       <a:round/>
@@ -5599,7 +5599,7 @@
                       <a:r>
                         <a:rPr lang="en-US" sz="1300" dirty="0">
                           <a:solidFill>
-                            <a:srgbClr val="CBD5E1"/>
+                            <a:srgbClr val="0F172A"/>
                           </a:solidFill>
                           <a:latin typeface="Segoe UI" pitchFamily="34" charset="0"/>
                           <a:ea typeface="Segoe UI" pitchFamily="34" charset="-122"/>
@@ -5617,7 +5617,7 @@
                   <a:tcPr marL="91440" marR="91440" marT="45720" marB="45720">
                     <a:lnL w="12700" cap="flat" cmpd="sng" algn="ctr">
                       <a:solidFill>
-                        <a:srgbClr val="334155"/>
+                        <a:srgbClr val="CBD5E1"/>
                       </a:solidFill>
                       <a:prstDash val="solid"/>
                       <a:round/>
@@ -5626,7 +5626,7 @@
                     </a:lnL>
                     <a:lnR w="12700" cap="flat" cmpd="sng" algn="ctr">
                       <a:solidFill>
-                        <a:srgbClr val="334155"/>
+                        <a:srgbClr val="CBD5E1"/>
                       </a:solidFill>
                       <a:prstDash val="solid"/>
                       <a:round/>
@@ -5635,7 +5635,7 @@
                     </a:lnR>
                     <a:lnT w="12700" cap="flat" cmpd="sng" algn="ctr">
                       <a:solidFill>
-                        <a:srgbClr val="334155"/>
+                        <a:srgbClr val="CBD5E1"/>
                       </a:solidFill>
                       <a:prstDash val="solid"/>
                       <a:round/>
@@ -5644,7 +5644,7 @@
                     </a:lnT>
                     <a:lnB w="12700" cap="flat" cmpd="sng" algn="ctr">
                       <a:solidFill>
-                        <a:srgbClr val="334155"/>
+                        <a:srgbClr val="CBD5E1"/>
                       </a:solidFill>
                       <a:prstDash val="solid"/>
                       <a:round/>
@@ -5664,7 +5664,7 @@
                       <a:r>
                         <a:rPr lang="en-US" sz="1300" dirty="0">
                           <a:solidFill>
-                            <a:srgbClr val="CBD5E1"/>
+                            <a:srgbClr val="0F172A"/>
                           </a:solidFill>
                           <a:latin typeface="Segoe UI" pitchFamily="34" charset="0"/>
                           <a:ea typeface="Segoe UI" pitchFamily="34" charset="-122"/>
@@ -5682,7 +5682,7 @@
                   <a:tcPr marL="91440" marR="91440" marT="45720" marB="45720">
                     <a:lnL w="12700" cap="flat" cmpd="sng" algn="ctr">
                       <a:solidFill>
-                        <a:srgbClr val="334155"/>
+                        <a:srgbClr val="CBD5E1"/>
                       </a:solidFill>
                       <a:prstDash val="solid"/>
                       <a:round/>
@@ -5691,7 +5691,7 @@
                     </a:lnL>
                     <a:lnR w="12700" cap="flat" cmpd="sng" algn="ctr">
                       <a:solidFill>
-                        <a:srgbClr val="334155"/>
+                        <a:srgbClr val="CBD5E1"/>
                       </a:solidFill>
                       <a:prstDash val="solid"/>
                       <a:round/>
@@ -5700,7 +5700,7 @@
                     </a:lnR>
                     <a:lnT w="12700" cap="flat" cmpd="sng" algn="ctr">
                       <a:solidFill>
-                        <a:srgbClr val="334155"/>
+                        <a:srgbClr val="CBD5E1"/>
                       </a:solidFill>
                       <a:prstDash val="solid"/>
                       <a:round/>
@@ -5709,7 +5709,7 @@
                     </a:lnT>
                     <a:lnB w="12700" cap="flat" cmpd="sng" algn="ctr">
                       <a:solidFill>
-                        <a:srgbClr val="334155"/>
+                        <a:srgbClr val="CBD5E1"/>
                       </a:solidFill>
                       <a:prstDash val="solid"/>
                       <a:round/>
@@ -5731,7 +5731,7 @@
                       <a:r>
                         <a:rPr lang="en-US" sz="1300" dirty="0">
                           <a:solidFill>
-                            <a:srgbClr val="CBD5E1"/>
+                            <a:srgbClr val="0F172A"/>
                           </a:solidFill>
                           <a:latin typeface="Segoe UI" pitchFamily="34" charset="0"/>
                           <a:ea typeface="Segoe UI" pitchFamily="34" charset="-122"/>
@@ -5749,7 +5749,7 @@
                   <a:tcPr marL="91440" marR="91440" marT="45720" marB="45720">
                     <a:lnL w="12700" cap="flat" cmpd="sng" algn="ctr">
                       <a:solidFill>
-                        <a:srgbClr val="334155"/>
+                        <a:srgbClr val="CBD5E1"/>
                       </a:solidFill>
                       <a:prstDash val="solid"/>
                       <a:round/>
@@ -5758,7 +5758,7 @@
                     </a:lnL>
                     <a:lnR w="12700" cap="flat" cmpd="sng" algn="ctr">
                       <a:solidFill>
-                        <a:srgbClr val="334155"/>
+                        <a:srgbClr val="CBD5E1"/>
                       </a:solidFill>
                       <a:prstDash val="solid"/>
                       <a:round/>
@@ -5767,7 +5767,7 @@
                     </a:lnR>
                     <a:lnT w="12700" cap="flat" cmpd="sng" algn="ctr">
                       <a:solidFill>
-                        <a:srgbClr val="334155"/>
+                        <a:srgbClr val="CBD5E1"/>
                       </a:solidFill>
                       <a:prstDash val="solid"/>
                       <a:round/>
@@ -5776,7 +5776,7 @@
                     </a:lnT>
                     <a:lnB w="12700" cap="flat" cmpd="sng" algn="ctr">
                       <a:solidFill>
-                        <a:srgbClr val="334155"/>
+                        <a:srgbClr val="CBD5E1"/>
                       </a:solidFill>
                       <a:prstDash val="solid"/>
                       <a:round/>
@@ -5796,7 +5796,7 @@
                       <a:r>
                         <a:rPr lang="en-US" sz="1300" dirty="0">
                           <a:solidFill>
-                            <a:srgbClr val="CBD5E1"/>
+                            <a:srgbClr val="0F172A"/>
                           </a:solidFill>
                           <a:latin typeface="Segoe UI" pitchFamily="34" charset="0"/>
                           <a:ea typeface="Segoe UI" pitchFamily="34" charset="-122"/>
@@ -5814,7 +5814,7 @@
                   <a:tcPr marL="91440" marR="91440" marT="45720" marB="45720">
                     <a:lnL w="12700" cap="flat" cmpd="sng" algn="ctr">
                       <a:solidFill>
-                        <a:srgbClr val="334155"/>
+                        <a:srgbClr val="CBD5E1"/>
                       </a:solidFill>
                       <a:prstDash val="solid"/>
                       <a:round/>
@@ -5823,7 +5823,7 @@
                     </a:lnL>
                     <a:lnR w="12700" cap="flat" cmpd="sng" algn="ctr">
                       <a:solidFill>
-                        <a:srgbClr val="334155"/>
+                        <a:srgbClr val="CBD5E1"/>
                       </a:solidFill>
                       <a:prstDash val="solid"/>
                       <a:round/>
@@ -5832,7 +5832,7 @@
                     </a:lnR>
                     <a:lnT w="12700" cap="flat" cmpd="sng" algn="ctr">
                       <a:solidFill>
-                        <a:srgbClr val="334155"/>
+                        <a:srgbClr val="CBD5E1"/>
                       </a:solidFill>
                       <a:prstDash val="solid"/>
                       <a:round/>
@@ -5841,7 +5841,7 @@
                     </a:lnT>
                     <a:lnB w="12700" cap="flat" cmpd="sng" algn="ctr">
                       <a:solidFill>
-                        <a:srgbClr val="334155"/>
+                        <a:srgbClr val="CBD5E1"/>
                       </a:solidFill>
                       <a:prstDash val="solid"/>
                       <a:round/>
@@ -5861,7 +5861,7 @@
                       <a:r>
                         <a:rPr lang="en-US" sz="1300" dirty="0">
                           <a:solidFill>
-                            <a:srgbClr val="CBD5E1"/>
+                            <a:srgbClr val="0F172A"/>
                           </a:solidFill>
                           <a:latin typeface="Segoe UI" pitchFamily="34" charset="0"/>
                           <a:ea typeface="Segoe UI" pitchFamily="34" charset="-122"/>
@@ -5879,7 +5879,7 @@
                   <a:tcPr marL="91440" marR="91440" marT="45720" marB="45720">
                     <a:lnL w="12700" cap="flat" cmpd="sng" algn="ctr">
                       <a:solidFill>
-                        <a:srgbClr val="334155"/>
+                        <a:srgbClr val="CBD5E1"/>
                       </a:solidFill>
                       <a:prstDash val="solid"/>
                       <a:round/>
@@ -5888,7 +5888,7 @@
                     </a:lnL>
                     <a:lnR w="12700" cap="flat" cmpd="sng" algn="ctr">
                       <a:solidFill>
-                        <a:srgbClr val="334155"/>
+                        <a:srgbClr val="CBD5E1"/>
                       </a:solidFill>
                       <a:prstDash val="solid"/>
                       <a:round/>
@@ -5897,7 +5897,7 @@
                     </a:lnR>
                     <a:lnT w="12700" cap="flat" cmpd="sng" algn="ctr">
                       <a:solidFill>
-                        <a:srgbClr val="334155"/>
+                        <a:srgbClr val="CBD5E1"/>
                       </a:solidFill>
                       <a:prstDash val="solid"/>
                       <a:round/>
@@ -5906,7 +5906,7 @@
                     </a:lnT>
                     <a:lnB w="12700" cap="flat" cmpd="sng" algn="ctr">
                       <a:solidFill>
-                        <a:srgbClr val="334155"/>
+                        <a:srgbClr val="CBD5E1"/>
                       </a:solidFill>
                       <a:prstDash val="solid"/>
                       <a:round/>
@@ -5934,7 +5934,7 @@
     <p:bg>
       <p:bgPr>
         <a:solidFill>
-          <a:srgbClr val="0F172A"/>
+          <a:srgbClr val="FFFFFF"/>
         </a:solidFill>
       </p:bgPr>
     </p:bg>
@@ -5979,7 +5979,7 @@
             <a:r>
               <a:rPr lang="en-US" sz="2600" b="1" dirty="0">
                 <a:solidFill>
-                  <a:srgbClr val="60A5FA"/>
+                  <a:srgbClr val="1E40AF"/>
                 </a:solidFill>
                 <a:latin typeface="Segoe UI" pitchFamily="34" charset="0"/>
                 <a:ea typeface="Segoe UI" pitchFamily="34" charset="-122"/>
@@ -6008,7 +6008,7 @@
           <a:noFill/>
           <a:ln w="25400">
             <a:solidFill>
-              <a:srgbClr val="334155"/>
+              <a:srgbClr val="E2E8F0"/>
             </a:solidFill>
             <a:prstDash val="solid"/>
           </a:ln>
@@ -6029,11 +6029,11 @@
             <a:avLst/>
           </a:prstGeom>
           <a:solidFill>
-            <a:srgbClr val="1E293B"/>
+            <a:srgbClr val="FEF3C7"/>
           </a:solidFill>
-          <a:ln w="25400">
+          <a:ln w="19050">
             <a:solidFill>
-              <a:srgbClr val="F59E0B"/>
+              <a:srgbClr val="FDE68A"/>
             </a:solidFill>
             <a:prstDash val="solid"/>
           </a:ln>
@@ -6066,7 +6066,7 @@
             <a:r>
               <a:rPr lang="en-US" sz="1800" b="1" dirty="0">
                 <a:solidFill>
-                  <a:srgbClr val="F59E0B"/>
+                  <a:srgbClr val="D97706"/>
                 </a:solidFill>
                 <a:latin typeface="Segoe UI" pitchFamily="34" charset="0"/>
                 <a:ea typeface="Segoe UI" pitchFamily="34" charset="-122"/>
@@ -6105,7 +6105,7 @@
             <a:r>
               <a:rPr lang="en-US" sz="2000" b="1" dirty="0">
                 <a:solidFill>
-                  <a:srgbClr val="FFFFFF"/>
+                  <a:srgbClr val="0F172A"/>
                 </a:solidFill>
                 <a:latin typeface="Segoe UI" pitchFamily="34" charset="0"/>
                 <a:ea typeface="Segoe UI" pitchFamily="34" charset="-122"/>
@@ -6132,11 +6132,11 @@
             <a:avLst/>
           </a:prstGeom>
           <a:solidFill>
-            <a:srgbClr val="1E293B"/>
+            <a:srgbClr val="F8FAFC"/>
           </a:solidFill>
-          <a:ln w="25400">
+          <a:ln w="19050">
             <a:solidFill>
-              <a:srgbClr val="3B82F6"/>
+              <a:srgbClr val="CBD5E1"/>
             </a:solidFill>
             <a:prstDash val="solid"/>
           </a:ln>
@@ -6169,13 +6169,13 @@
             <a:r>
               <a:rPr lang="en-US" sz="1800" b="1" dirty="0">
                 <a:solidFill>
-                  <a:srgbClr val="3B82F6"/>
-                </a:solidFill>
-                <a:latin typeface="Segoe UI" pitchFamily="34" charset="0"/>
-                <a:ea typeface="Segoe UI" pitchFamily="34" charset="-122"/>
-                <a:cs typeface="Segoe UI" pitchFamily="34" charset="-120"/>
-              </a:rPr>
-              <a:t>Step 1: Input Validation</a:t>
+                  <a:srgbClr val="1E40AF"/>
+                </a:solidFill>
+                <a:latin typeface="Segoe UI" pitchFamily="34" charset="0"/>
+                <a:ea typeface="Segoe UI" pitchFamily="34" charset="-122"/>
+                <a:cs typeface="Segoe UI" pitchFamily="34" charset="-120"/>
+              </a:rPr>
+              <a:t>Step 1: Form Validation</a:t>
             </a:r>
             <a:endParaRPr lang="en-US" sz="1800" dirty="0"/>
           </a:p>
@@ -6208,7 +6208,7 @@
             <a:r>
               <a:rPr lang="en-US" sz="1400" dirty="0">
                 <a:solidFill>
-                  <a:srgbClr val="CBD5E1"/>
+                  <a:srgbClr val="475569"/>
                 </a:solidFill>
                 <a:latin typeface="Segoe UI" pitchFamily="34" charset="0"/>
                 <a:ea typeface="Segoe UI" pitchFamily="34" charset="-122"/>
@@ -6225,7 +6225,7 @@
             <a:r>
               <a:rPr lang="en-US" sz="1400" dirty="0">
                 <a:solidFill>
-                  <a:srgbClr val="CBD5E1"/>
+                  <a:srgbClr val="475569"/>
                 </a:solidFill>
                 <a:latin typeface="Segoe UI" pitchFamily="34" charset="0"/>
                 <a:ea typeface="Segoe UI" pitchFamily="34" charset="-122"/>
@@ -6242,7 +6242,7 @@
             <a:r>
               <a:rPr lang="en-US" sz="1400" dirty="0">
                 <a:solidFill>
-                  <a:srgbClr val="CBD5E1"/>
+                  <a:srgbClr val="475569"/>
                 </a:solidFill>
                 <a:latin typeface="Segoe UI" pitchFamily="34" charset="0"/>
                 <a:ea typeface="Segoe UI" pitchFamily="34" charset="-122"/>
@@ -6269,11 +6269,11 @@
             <a:avLst/>
           </a:prstGeom>
           <a:solidFill>
-            <a:srgbClr val="1E293B"/>
+            <a:srgbClr val="F8FAFC"/>
           </a:solidFill>
-          <a:ln w="25400">
+          <a:ln w="19050">
             <a:solidFill>
-              <a:srgbClr val="10B981"/>
+              <a:srgbClr val="CBD5E1"/>
             </a:solidFill>
             <a:prstDash val="solid"/>
           </a:ln>
@@ -6306,13 +6306,13 @@
             <a:r>
               <a:rPr lang="en-US" sz="1800" b="1" dirty="0">
                 <a:solidFill>
-                  <a:srgbClr val="10B981"/>
-                </a:solidFill>
-                <a:latin typeface="Segoe UI" pitchFamily="34" charset="0"/>
-                <a:ea typeface="Segoe UI" pitchFamily="34" charset="-122"/>
-                <a:cs typeface="Segoe UI" pitchFamily="34" charset="-120"/>
-              </a:rPr>
-              <a:t>Step 2: Order Saving &amp; Reference</a:t>
+                  <a:srgbClr val="059669"/>
+                </a:solidFill>
+                <a:latin typeface="Segoe UI" pitchFamily="34" charset="0"/>
+                <a:ea typeface="Segoe UI" pitchFamily="34" charset="-122"/>
+                <a:cs typeface="Segoe UI" pitchFamily="34" charset="-120"/>
+              </a:rPr>
+              <a:t>Step 2: Order Saving &amp; Pass Summary</a:t>
             </a:r>
             <a:endParaRPr lang="en-US" sz="1800" dirty="0"/>
           </a:p>
@@ -6345,7 +6345,7 @@
             <a:r>
               <a:rPr lang="en-US" sz="1400" dirty="0">
                 <a:solidFill>
-                  <a:srgbClr val="CBD5E1"/>
+                  <a:srgbClr val="475569"/>
                 </a:solidFill>
                 <a:latin typeface="Segoe UI" pitchFamily="34" charset="0"/>
                 <a:ea typeface="Segoe UI" pitchFamily="34" charset="-122"/>
@@ -6362,7 +6362,7 @@
             <a:r>
               <a:rPr lang="en-US" sz="1400" dirty="0">
                 <a:solidFill>
-                  <a:srgbClr val="CBD5E1"/>
+                  <a:srgbClr val="475569"/>
                 </a:solidFill>
                 <a:latin typeface="Segoe UI" pitchFamily="34" charset="0"/>
                 <a:ea typeface="Segoe UI" pitchFamily="34" charset="-122"/>
@@ -6379,7 +6379,7 @@
             <a:r>
               <a:rPr lang="en-US" sz="1400" dirty="0">
                 <a:solidFill>
-                  <a:srgbClr val="CBD5E1"/>
+                  <a:srgbClr val="475569"/>
                 </a:solidFill>
                 <a:latin typeface="Segoe UI" pitchFamily="34" charset="0"/>
                 <a:ea typeface="Segoe UI" pitchFamily="34" charset="-122"/>
@@ -6405,7 +6405,7 @@
     <p:bg>
       <p:bgPr>
         <a:solidFill>
-          <a:srgbClr val="0F172A"/>
+          <a:srgbClr val="FFFFFF"/>
         </a:solidFill>
       </p:bgPr>
     </p:bg>
@@ -6450,7 +6450,7 @@
             <a:r>
               <a:rPr lang="en-US" sz="2600" b="1" dirty="0">
                 <a:solidFill>
-                  <a:srgbClr val="60A5FA"/>
+                  <a:srgbClr val="1E40AF"/>
                 </a:solidFill>
                 <a:latin typeface="Segoe UI" pitchFamily="34" charset="0"/>
                 <a:ea typeface="Segoe UI" pitchFamily="34" charset="-122"/>
@@ -6479,7 +6479,7 @@
           <a:noFill/>
           <a:ln w="25400">
             <a:solidFill>
-              <a:srgbClr val="334155"/>
+              <a:srgbClr val="E2E8F0"/>
             </a:solidFill>
             <a:prstDash val="solid"/>
           </a:ln>
@@ -6500,11 +6500,11 @@
             <a:avLst/>
           </a:prstGeom>
           <a:solidFill>
-            <a:srgbClr val="1E293B"/>
+            <a:srgbClr val="F8FAFC"/>
           </a:solidFill>
-          <a:ln w="25400">
+          <a:ln w="19050">
             <a:solidFill>
-              <a:srgbClr val="3B82F6"/>
+              <a:srgbClr val="CBD5E1"/>
             </a:solidFill>
             <a:prstDash val="solid"/>
           </a:ln>
@@ -6537,7 +6537,7 @@
             <a:r>
               <a:rPr lang="en-US" sz="2000" b="1" dirty="0">
                 <a:solidFill>
-                  <a:srgbClr val="3B82F6"/>
+                  <a:srgbClr val="1E40AF"/>
                 </a:solidFill>
                 <a:latin typeface="Segoe UI" pitchFamily="34" charset="0"/>
                 <a:ea typeface="Segoe UI" pitchFamily="34" charset="-122"/>
@@ -6576,7 +6576,7 @@
             <a:r>
               <a:rPr lang="en-US" sz="1300" b="1" dirty="0">
                 <a:solidFill>
-                  <a:srgbClr val="60A5FA"/>
+                  <a:srgbClr val="2563EB"/>
                 </a:solidFill>
                 <a:latin typeface="Consolas" pitchFamily="34" charset="0"/>
                 <a:ea typeface="Consolas" pitchFamily="34" charset="-122"/>
@@ -6615,7 +6615,7 @@
             <a:r>
               <a:rPr lang="en-US" sz="1400" dirty="0">
                 <a:solidFill>
-                  <a:srgbClr val="CBD5E1"/>
+                  <a:srgbClr val="475569"/>
                 </a:solidFill>
                 <a:latin typeface="Segoe UI" pitchFamily="34" charset="0"/>
                 <a:ea typeface="Segoe UI" pitchFamily="34" charset="-122"/>
@@ -6642,11 +6642,11 @@
             <a:avLst/>
           </a:prstGeom>
           <a:solidFill>
-            <a:srgbClr val="1E293B"/>
+            <a:srgbClr val="F8FAFC"/>
           </a:solidFill>
-          <a:ln w="25400">
+          <a:ln w="19050">
             <a:solidFill>
-              <a:srgbClr val="10B981"/>
+              <a:srgbClr val="CBD5E1"/>
             </a:solidFill>
             <a:prstDash val="solid"/>
           </a:ln>
@@ -6679,7 +6679,7 @@
             <a:r>
               <a:rPr lang="en-US" sz="2000" b="1" dirty="0">
                 <a:solidFill>
-                  <a:srgbClr val="10B981"/>
+                  <a:srgbClr val="059669"/>
                 </a:solidFill>
                 <a:latin typeface="Segoe UI" pitchFamily="34" charset="0"/>
                 <a:ea typeface="Segoe UI" pitchFamily="34" charset="-122"/>
@@ -6718,7 +6718,7 @@
             <a:r>
               <a:rPr lang="en-US" sz="1300" b="1" dirty="0">
                 <a:solidFill>
-                  <a:srgbClr val="60A5FA"/>
+                  <a:srgbClr val="2563EB"/>
                 </a:solidFill>
                 <a:latin typeface="Consolas" pitchFamily="34" charset="0"/>
                 <a:ea typeface="Consolas" pitchFamily="34" charset="-122"/>
@@ -6757,7 +6757,7 @@
             <a:r>
               <a:rPr lang="en-US" sz="1400" dirty="0">
                 <a:solidFill>
-                  <a:srgbClr val="CBD5E1"/>
+                  <a:srgbClr val="475569"/>
                 </a:solidFill>
                 <a:latin typeface="Segoe UI" pitchFamily="34" charset="0"/>
                 <a:ea typeface="Segoe UI" pitchFamily="34" charset="-122"/>
@@ -6784,11 +6784,11 @@
             <a:avLst/>
           </a:prstGeom>
           <a:solidFill>
-            <a:srgbClr val="1E293B"/>
+            <a:srgbClr val="F8FAFC"/>
           </a:solidFill>
-          <a:ln w="25400">
+          <a:ln w="19050">
             <a:solidFill>
-              <a:srgbClr val="F59E0B"/>
+              <a:srgbClr val="CBD5E1"/>
             </a:solidFill>
             <a:prstDash val="solid"/>
           </a:ln>
@@ -6821,7 +6821,7 @@
             <a:r>
               <a:rPr lang="en-US" sz="2000" b="1" dirty="0">
                 <a:solidFill>
-                  <a:srgbClr val="F59E0B"/>
+                  <a:srgbClr val="D97706"/>
                 </a:solidFill>
                 <a:latin typeface="Segoe UI" pitchFamily="34" charset="0"/>
                 <a:ea typeface="Segoe UI" pitchFamily="34" charset="-122"/>
@@ -6860,7 +6860,7 @@
             <a:r>
               <a:rPr lang="en-US" sz="1300" b="1" dirty="0">
                 <a:solidFill>
-                  <a:srgbClr val="60A5FA"/>
+                  <a:srgbClr val="2563EB"/>
                 </a:solidFill>
                 <a:latin typeface="Consolas" pitchFamily="34" charset="0"/>
                 <a:ea typeface="Consolas" pitchFamily="34" charset="-122"/>
@@ -6899,7 +6899,7 @@
             <a:r>
               <a:rPr lang="en-US" sz="1400" dirty="0">
                 <a:solidFill>
-                  <a:srgbClr val="CBD5E1"/>
+                  <a:srgbClr val="475569"/>
                 </a:solidFill>
                 <a:latin typeface="Segoe UI" pitchFamily="34" charset="0"/>
                 <a:ea typeface="Segoe UI" pitchFamily="34" charset="-122"/>
@@ -6925,7 +6925,7 @@
     <p:bg>
       <p:bgPr>
         <a:solidFill>
-          <a:srgbClr val="0F172A"/>
+          <a:srgbClr val="FFFFFF"/>
         </a:solidFill>
       </p:bgPr>
     </p:bg>
@@ -6970,7 +6970,7 @@
             <a:r>
               <a:rPr lang="en-US" sz="2600" b="1" dirty="0">
                 <a:solidFill>
-                  <a:srgbClr val="60A5FA"/>
+                  <a:srgbClr val="1E40AF"/>
                 </a:solidFill>
                 <a:latin typeface="Segoe UI" pitchFamily="34" charset="0"/>
                 <a:ea typeface="Segoe UI" pitchFamily="34" charset="-122"/>
@@ -6999,7 +6999,7 @@
           <a:noFill/>
           <a:ln w="25400">
             <a:solidFill>
-              <a:srgbClr val="334155"/>
+              <a:srgbClr val="E2E8F0"/>
             </a:solidFill>
             <a:prstDash val="solid"/>
           </a:ln>
@@ -7020,11 +7020,11 @@
             <a:avLst/>
           </a:prstGeom>
           <a:solidFill>
-            <a:srgbClr val="1E293B"/>
+            <a:srgbClr val="ECFDF5"/>
           </a:solidFill>
-          <a:ln w="25400">
+          <a:ln w="19050">
             <a:solidFill>
-              <a:srgbClr val="10B981"/>
+              <a:srgbClr val="A7F3D0"/>
             </a:solidFill>
             <a:prstDash val="solid"/>
           </a:ln>
@@ -7057,7 +7057,7 @@
             <a:r>
               <a:rPr lang="en-US" sz="2000" b="1" dirty="0">
                 <a:solidFill>
-                  <a:srgbClr val="10B981"/>
+                  <a:srgbClr val="059669"/>
                 </a:solidFill>
                 <a:latin typeface="Segoe UI" pitchFamily="34" charset="0"/>
                 <a:ea typeface="Segoe UI" pitchFamily="34" charset="-122"/>
@@ -7096,7 +7096,7 @@
             <a:r>
               <a:rPr lang="en-US" sz="1500" dirty="0">
                 <a:solidFill>
-                  <a:srgbClr val="CBD5E1"/>
+                  <a:srgbClr val="0F172A"/>
                 </a:solidFill>
                 <a:latin typeface="Segoe UI" pitchFamily="34" charset="0"/>
                 <a:ea typeface="Segoe UI" pitchFamily="34" charset="-122"/>
@@ -7119,7 +7119,7 @@
             <a:r>
               <a:rPr lang="en-US" sz="1500" dirty="0">
                 <a:solidFill>
-                  <a:srgbClr val="CBD5E1"/>
+                  <a:srgbClr val="0F172A"/>
                 </a:solidFill>
                 <a:latin typeface="Segoe UI" pitchFamily="34" charset="0"/>
                 <a:ea typeface="Segoe UI" pitchFamily="34" charset="-122"/>
@@ -7136,7 +7136,7 @@
             <a:r>
               <a:rPr lang="en-US" sz="1500" dirty="0">
                 <a:solidFill>
-                  <a:srgbClr val="CBD5E1"/>
+                  <a:srgbClr val="0F172A"/>
                 </a:solidFill>
                 <a:latin typeface="Segoe UI" pitchFamily="34" charset="0"/>
                 <a:ea typeface="Segoe UI" pitchFamily="34" charset="-122"/>
@@ -7153,7 +7153,7 @@
             <a:r>
               <a:rPr lang="en-US" sz="1500" dirty="0">
                 <a:solidFill>
-                  <a:srgbClr val="CBD5E1"/>
+                  <a:srgbClr val="0F172A"/>
                 </a:solidFill>
                 <a:latin typeface="Segoe UI" pitchFamily="34" charset="0"/>
                 <a:ea typeface="Segoe UI" pitchFamily="34" charset="-122"/>
@@ -7176,7 +7176,7 @@
             <a:r>
               <a:rPr lang="en-US" sz="1500" dirty="0">
                 <a:solidFill>
-                  <a:srgbClr val="CBD5E1"/>
+                  <a:srgbClr val="0F172A"/>
                 </a:solidFill>
                 <a:latin typeface="Segoe UI" pitchFamily="34" charset="0"/>
                 <a:ea typeface="Segoe UI" pitchFamily="34" charset="-122"/>
@@ -7193,7 +7193,7 @@
             <a:r>
               <a:rPr lang="en-US" sz="1500" dirty="0">
                 <a:solidFill>
-                  <a:srgbClr val="CBD5E1"/>
+                  <a:srgbClr val="0F172A"/>
                 </a:solidFill>
                 <a:latin typeface="Segoe UI" pitchFamily="34" charset="0"/>
                 <a:ea typeface="Segoe UI" pitchFamily="34" charset="-122"/>
@@ -7220,11 +7220,11 @@
             <a:avLst/>
           </a:prstGeom>
           <a:solidFill>
-            <a:srgbClr val="1E293B"/>
+            <a:srgbClr val="EFF6FF"/>
           </a:solidFill>
-          <a:ln w="25400">
+          <a:ln w="19050">
             <a:solidFill>
-              <a:srgbClr val="60A5FA"/>
+              <a:srgbClr val="BFDBFE"/>
             </a:solidFill>
             <a:prstDash val="solid"/>
           </a:ln>
@@ -7257,7 +7257,7 @@
             <a:r>
               <a:rPr lang="en-US" sz="2000" b="1" dirty="0">
                 <a:solidFill>
-                  <a:srgbClr val="60A5FA"/>
+                  <a:srgbClr val="1E40AF"/>
                 </a:solidFill>
                 <a:latin typeface="Segoe UI" pitchFamily="34" charset="0"/>
                 <a:ea typeface="Segoe UI" pitchFamily="34" charset="-122"/>
@@ -7296,7 +7296,7 @@
             <a:r>
               <a:rPr lang="en-US" sz="1500" dirty="0">
                 <a:solidFill>
-                  <a:srgbClr val="CBD5E1"/>
+                  <a:srgbClr val="0F172A"/>
                 </a:solidFill>
                 <a:latin typeface="Segoe UI" pitchFamily="34" charset="0"/>
                 <a:ea typeface="Segoe UI" pitchFamily="34" charset="-122"/>
@@ -7319,7 +7319,7 @@
             <a:r>
               <a:rPr lang="en-US" sz="1500" dirty="0">
                 <a:solidFill>
-                  <a:srgbClr val="CBD5E1"/>
+                  <a:srgbClr val="0F172A"/>
                 </a:solidFill>
                 <a:latin typeface="Segoe UI" pitchFamily="34" charset="0"/>
                 <a:ea typeface="Segoe UI" pitchFamily="34" charset="-122"/>
@@ -7336,7 +7336,7 @@
             <a:r>
               <a:rPr lang="en-US" sz="1500" dirty="0">
                 <a:solidFill>
-                  <a:srgbClr val="CBD5E1"/>
+                  <a:srgbClr val="0F172A"/>
                 </a:solidFill>
                 <a:latin typeface="Segoe UI" pitchFamily="34" charset="0"/>
                 <a:ea typeface="Segoe UI" pitchFamily="34" charset="-122"/>
@@ -7353,7 +7353,7 @@
             <a:r>
               <a:rPr lang="en-US" sz="1500" dirty="0">
                 <a:solidFill>
-                  <a:srgbClr val="CBD5E1"/>
+                  <a:srgbClr val="0F172A"/>
                 </a:solidFill>
                 <a:latin typeface="Segoe UI" pitchFamily="34" charset="0"/>
                 <a:ea typeface="Segoe UI" pitchFamily="34" charset="-122"/>
@@ -7370,7 +7370,7 @@
             <a:r>
               <a:rPr lang="en-US" sz="1500" dirty="0">
                 <a:solidFill>
-                  <a:srgbClr val="CBD5E1"/>
+                  <a:srgbClr val="0F172A"/>
                 </a:solidFill>
                 <a:latin typeface="Segoe UI" pitchFamily="34" charset="0"/>
                 <a:ea typeface="Segoe UI" pitchFamily="34" charset="-122"/>
@@ -7396,7 +7396,7 @@
     <p:bg>
       <p:bgPr>
         <a:solidFill>
-          <a:srgbClr val="0F172A"/>
+          <a:srgbClr val="FFFFFF"/>
         </a:solidFill>
       </p:bgPr>
     </p:bg>
@@ -7441,7 +7441,7 @@
             <a:r>
               <a:rPr lang="en-US" sz="2600" b="1" dirty="0">
                 <a:solidFill>
-                  <a:srgbClr val="60A5FA"/>
+                  <a:srgbClr val="1E40AF"/>
                 </a:solidFill>
                 <a:latin typeface="Segoe UI" pitchFamily="34" charset="0"/>
                 <a:ea typeface="Segoe UI" pitchFamily="34" charset="-122"/>
@@ -7470,7 +7470,7 @@
           <a:noFill/>
           <a:ln w="25400">
             <a:solidFill>
-              <a:srgbClr val="334155"/>
+              <a:srgbClr val="E2E8F0"/>
             </a:solidFill>
             <a:prstDash val="solid"/>
           </a:ln>
@@ -7491,11 +7491,11 @@
             <a:avLst/>
           </a:prstGeom>
           <a:solidFill>
-            <a:srgbClr val="1E293B"/>
+            <a:srgbClr val="F8FAFC"/>
           </a:solidFill>
-          <a:ln w="25400">
+          <a:ln w="19050">
             <a:solidFill>
-              <a:srgbClr val="3B82F6"/>
+              <a:srgbClr val="CBD5E1"/>
             </a:solidFill>
             <a:prstDash val="solid"/>
           </a:ln>
@@ -7528,7 +7528,7 @@
             <a:r>
               <a:rPr lang="en-US" sz="1800" b="1" dirty="0">
                 <a:solidFill>
-                  <a:srgbClr val="3B82F6"/>
+                  <a:srgbClr val="1E40AF"/>
                 </a:solidFill>
                 <a:latin typeface="Segoe UI" pitchFamily="34" charset="0"/>
                 <a:ea typeface="Segoe UI" pitchFamily="34" charset="-122"/>
@@ -7567,7 +7567,7 @@
             <a:r>
               <a:rPr lang="en-US" sz="1400" dirty="0">
                 <a:solidFill>
-                  <a:srgbClr val="CBD5E1"/>
+                  <a:srgbClr val="475569"/>
                 </a:solidFill>
                 <a:latin typeface="Segoe UI" pitchFamily="34" charset="0"/>
                 <a:ea typeface="Segoe UI" pitchFamily="34" charset="-122"/>
@@ -7594,11 +7594,11 @@
             <a:avLst/>
           </a:prstGeom>
           <a:solidFill>
-            <a:srgbClr val="1E293B"/>
+            <a:srgbClr val="F8FAFC"/>
           </a:solidFill>
-          <a:ln w="25400">
+          <a:ln w="19050">
             <a:solidFill>
-              <a:srgbClr val="10B981"/>
+              <a:srgbClr val="CBD5E1"/>
             </a:solidFill>
             <a:prstDash val="solid"/>
           </a:ln>
@@ -7631,7 +7631,7 @@
             <a:r>
               <a:rPr lang="en-US" sz="1800" b="1" dirty="0">
                 <a:solidFill>
-                  <a:srgbClr val="10B981"/>
+                  <a:srgbClr val="059669"/>
                 </a:solidFill>
                 <a:latin typeface="Segoe UI" pitchFamily="34" charset="0"/>
                 <a:ea typeface="Segoe UI" pitchFamily="34" charset="-122"/>
@@ -7670,7 +7670,7 @@
             <a:r>
               <a:rPr lang="en-US" sz="1400" dirty="0">
                 <a:solidFill>
-                  <a:srgbClr val="CBD5E1"/>
+                  <a:srgbClr val="475569"/>
                 </a:solidFill>
                 <a:latin typeface="Segoe UI" pitchFamily="34" charset="0"/>
                 <a:ea typeface="Segoe UI" pitchFamily="34" charset="-122"/>
@@ -7697,11 +7697,11 @@
             <a:avLst/>
           </a:prstGeom>
           <a:solidFill>
-            <a:srgbClr val="1E293B"/>
+            <a:srgbClr val="F8FAFC"/>
           </a:solidFill>
-          <a:ln w="25400">
+          <a:ln w="19050">
             <a:solidFill>
-              <a:srgbClr val="F59E0B"/>
+              <a:srgbClr val="CBD5E1"/>
             </a:solidFill>
             <a:prstDash val="solid"/>
           </a:ln>
@@ -7734,7 +7734,7 @@
             <a:r>
               <a:rPr lang="en-US" sz="1800" b="1" dirty="0">
                 <a:solidFill>
-                  <a:srgbClr val="F59E0B"/>
+                  <a:srgbClr val="D97706"/>
                 </a:solidFill>
                 <a:latin typeface="Segoe UI" pitchFamily="34" charset="0"/>
                 <a:ea typeface="Segoe UI" pitchFamily="34" charset="-122"/>
@@ -7773,7 +7773,7 @@
             <a:r>
               <a:rPr lang="en-US" sz="1400" dirty="0">
                 <a:solidFill>
-                  <a:srgbClr val="CBD5E1"/>
+                  <a:srgbClr val="475569"/>
                 </a:solidFill>
                 <a:latin typeface="Segoe UI" pitchFamily="34" charset="0"/>
                 <a:ea typeface="Segoe UI" pitchFamily="34" charset="-122"/>

</xml_diff>